<commit_message>
Presentation: PDF export, LangSmith slide, shape-drawn charts, live URL
- charts drawn from shapes (native pptx charts were dropped by the Keynote/PDF export)
- new slide 12: LangSmith tracing (screenshot cropped to exclude account details)
- demo slide shows the live URL; conclusions list the deployment as done
- tests no longer send fake-LLM runs to LangSmith (tests/conftest.py)

Co-Authored-By: Claude Opus 5.5 (1M context) <noreply@anthropic.com>
</commit_message>
<xml_diff>
--- a/docs/deck/Bloom_final_presentation.pptx
+++ b/docs/deck/Bloom_final_presentation.pptx
@@ -18,9 +18,10 @@
     <p:sldId id="266" r:id="rId12"/>
     <p:sldId id="267" r:id="rId13"/>
     <p:sldId id="268" r:id="rId14"/>
+    <p:sldId id="269" r:id="rId15"/>
   </p:sldIdLst>
   <p:notesMasterIdLst>
-    <p:notesMasterId r:id="rId15"/>
+    <p:notesMasterId r:id="rId16"/>
   </p:notesMasterIdLst>
   <p:sldSz cx="9144000" cy="5143500"/>
   <p:notesSz cx="5143500" cy="9144000"/>
@@ -117,626 +118,6 @@
     </a:lvl9pPr>
   </p:defaultTextStyle>
 </p:presentation>
-</file>
-
-<file path=ppt/charts/chart1.xml><?xml version="1.0" encoding="utf-8"?>
-<c:chartSpace xmlns:c="http://schemas.openxmlformats.org/drawingml/2006/chart" xmlns:a="http://schemas.openxmlformats.org/drawingml/2006/main" xmlns:r="http://schemas.openxmlformats.org/officeDocument/2006/relationships">
-  <c:date1904 val="0"/>
-  <c:roundedCorners val="1"/>
-  <c:chart>
-    <c:title>
-      <c:tx>
-        <c:rich>
-          <a:bodyPr/>
-          <a:lstStyle/>
-          <a:p>
-            <a:pPr>
-              <a:defRPr sz="1200" b="0" i="0" u="none" strike="noStrike">
-                <a:solidFill>
-                  <a:srgbClr val="2B2A28"/>
-                </a:solidFill>
-                <a:latin typeface="Arial"/>
-              </a:defRPr>
-            </a:pPr>
-            <a:r>
-              <a:rPr sz="1200" b="0" i="0" u="none" strike="noStrike">
-                <a:solidFill>
-                  <a:srgbClr val="2B2A28"/>
-                </a:solidFill>
-                <a:latin typeface="Arial"/>
-              </a:rPr>
-              <a:t>Golden set by category</a:t>
-            </a:r>
-          </a:p>
-        </c:rich>
-      </c:tx>
-      <c:layout/>
-      <c:overlay val="0"/>
-    </c:title>
-    <c:autoTitleDeleted val="0"/>
-    <c:plotArea>
-      <c:layout/>
-      <c:barChart>
-        <c:barDir val="bar"/>
-        <c:grouping val="clustered"/>
-        <c:varyColors val="0"/>
-        <c:ser>
-          <c:idx val="0"/>
-          <c:order val="0"/>
-          <c:tx>
-            <c:strRef>
-              <c:f>Sheet1!$B$1</c:f>
-              <c:strCache>
-                <c:ptCount val="1"/>
-                <c:pt idx="0">
-                  <c:v>examples</c:v>
-                </c:pt>
-              </c:strCache>
-            </c:strRef>
-          </c:tx>
-          <c:spPr>
-            <a:solidFill>
-              <a:srgbClr val="138A72"/>
-            </a:solidFill>
-            <a:effectLst/>
-          </c:spPr>
-          <c:invertIfNegative val="0"/>
-          <c:dLbls>
-            <c:numFmt formatCode="#,##0" sourceLinked="0"/>
-            <c:txPr>
-              <a:bodyPr/>
-              <a:lstStyle/>
-              <a:p>
-                <a:pPr>
-                  <a:defRPr b="0" i="0" strike="noStrike" sz="1000" u="none">
-                    <a:solidFill>
-                      <a:srgbClr val="2B2A28"/>
-                    </a:solidFill>
-                    <a:latin typeface="Arial"/>
-                  </a:defRPr>
-                </a:pPr>
-              </a:p>
-            </c:txPr>
-            <c:showLegendKey val="0"/>
-            <c:showVal val="1"/>
-            <c:showCatName val="0"/>
-            <c:showSerName val="0"/>
-            <c:showPercent val="0"/>
-            <c:showBubbleSize val="0"/>
-            <c:showLeaderLines val="0"/>
-          </c:dLbls>
-          <c:cat>
-            <c:multiLvlStrRef>
-              <c:f>Sheet1!$A$2:$A$9</c:f>
-              <c:multiLvlStrCache>
-                <c:ptCount val="8"/>
-                <c:lvl>
-                  <c:pt idx="0">
-                    <c:v>evidence</c:v>
-                  </c:pt>
-                  <c:pt idx="1">
-                    <c:v>data</c:v>
-                  </c:pt>
-                  <c:pt idx="2">
-                    <c:v>red flag</c:v>
-                  </c:pt>
-                  <c:pt idx="3">
-                    <c:v>near miss</c:v>
-                  </c:pt>
-                  <c:pt idx="4">
-                    <c:v>injection</c:v>
-                  </c:pt>
-                  <c:pt idx="5">
-                    <c:v>off topic</c:v>
-                  </c:pt>
-                  <c:pt idx="6">
-                    <c:v>smalltalk</c:v>
-                  </c:pt>
-                  <c:pt idx="7">
-                    <c:v>goal</c:v>
-                  </c:pt>
-                </c:lvl>
-              </c:multiLvlStrCache>
-            </c:multiLvlStrRef>
-          </c:cat>
-          <c:val>
-            <c:numRef>
-              <c:f>Sheet1!$B$2:$B$9</c:f>
-              <c:numCache>
-                <c:formatCode>General</c:formatCode>
-                <c:ptCount val="8"/>
-                <c:pt idx="0">
-                  <c:v>14</c:v>
-                </c:pt>
-                <c:pt idx="1">
-                  <c:v>9</c:v>
-                </c:pt>
-                <c:pt idx="2">
-                  <c:v>8</c:v>
-                </c:pt>
-                <c:pt idx="3">
-                  <c:v>4</c:v>
-                </c:pt>
-                <c:pt idx="4">
-                  <c:v>2</c:v>
-                </c:pt>
-                <c:pt idx="5">
-                  <c:v>2</c:v>
-                </c:pt>
-                <c:pt idx="6">
-                  <c:v>1</c:v>
-                </c:pt>
-                <c:pt idx="7">
-                  <c:v>3</c:v>
-                </c:pt>
-              </c:numCache>
-            </c:numRef>
-          </c:val>
-        </c:ser>
-        <c:dLbls>
-          <c:numFmt formatCode="#,##0" sourceLinked="0"/>
-          <c:txPr>
-            <a:bodyPr/>
-            <a:lstStyle/>
-            <a:p>
-              <a:pPr>
-                <a:defRPr b="0" i="0" strike="noStrike" sz="1000" u="none">
-                  <a:solidFill>
-                    <a:srgbClr val="2B2A28"/>
-                  </a:solidFill>
-                  <a:latin typeface="Arial"/>
-                </a:defRPr>
-              </a:pPr>
-            </a:p>
-          </c:txPr>
-          <c:showLegendKey val="0"/>
-          <c:showVal val="1"/>
-          <c:showCatName val="0"/>
-          <c:showSerName val="0"/>
-          <c:showPercent val="0"/>
-          <c:showBubbleSize val="0"/>
-          <c:showLeaderLines val="0"/>
-        </c:dLbls>
-        <c:gapWidth val="150"/>
-        <c:overlap val="0"/>
-        <c:axId val="2094734554"/>
-        <c:axId val="2094734552"/>
-        <c:axId val="2094734556"/>
-      </c:barChart>
-      <c:catAx>
-        <c:axId val="2094734554"/>
-        <c:scaling>
-          <c:orientation val="maxMin"/>
-        </c:scaling>
-        <c:delete val="0"/>
-        <c:axPos val="l"/>
-        <c:numFmt formatCode="General" sourceLinked="1"/>
-        <c:majorTickMark val="out"/>
-        <c:minorTickMark val="none"/>
-        <c:tickLblPos val="nextTo"/>
-        <c:spPr>
-          <a:ln w="12700" cap="flat">
-            <a:solidFill>
-              <a:srgbClr val="888888"/>
-            </a:solidFill>
-            <a:prstDash val="solid"/>
-            <a:round/>
-          </a:ln>
-        </c:spPr>
-        <c:txPr>
-          <a:bodyPr/>
-          <a:lstStyle/>
-          <a:p>
-            <a:pPr>
-              <a:defRPr sz="1100" b="0" i="0" u="none" strike="noStrike">
-                <a:solidFill>
-                  <a:srgbClr val="2B2A28"/>
-                </a:solidFill>
-                <a:latin typeface="Arial"/>
-              </a:defRPr>
-            </a:pPr>
-            <a:endParaRPr lang="en-US"/>
-          </a:p>
-        </c:txPr>
-        <c:crossAx val="2094734552"/>
-        <c:crosses val="autoZero"/>
-        <c:auto val="1"/>
-        <c:lblAlgn val="ctr"/>
-        <c:noMultiLvlLbl val="1"/>
-      </c:catAx>
-      <c:valAx>
-        <c:axId val="2094734552"/>
-        <c:scaling>
-          <c:orientation val="minMax"/>
-        </c:scaling>
-        <c:delete val="1"/>
-        <c:axPos val="b"/>
-        <c:numFmt formatCode="General" sourceLinked="0"/>
-        <c:majorTickMark val="out"/>
-        <c:minorTickMark val="none"/>
-        <c:tickLblPos val="low"/>
-        <c:spPr>
-          <a:ln w="12700" cap="flat">
-            <a:solidFill>
-              <a:srgbClr val="888888"/>
-            </a:solidFill>
-            <a:prstDash val="solid"/>
-            <a:round/>
-          </a:ln>
-        </c:spPr>
-        <c:txPr>
-          <a:bodyPr/>
-          <a:lstStyle/>
-          <a:p>
-            <a:pPr>
-              <a:defRPr sz="1200" b="0" i="0" u="none" strike="noStrike">
-                <a:solidFill>
-                  <a:srgbClr val="000000"/>
-                </a:solidFill>
-                <a:latin typeface="Arial"/>
-              </a:defRPr>
-            </a:pPr>
-            <a:endParaRPr lang="en-US"/>
-          </a:p>
-        </c:txPr>
-        <c:crossAx val="2094734554"/>
-        <c:crosses val="autoZero"/>
-        <c:crossBetween val="between"/>
-      </c:valAx>
-      <c:spPr>
-        <a:noFill/>
-        <a:ln>
-          <a:noFill/>
-        </a:ln>
-        <a:effectLst/>
-      </c:spPr>
-    </c:plotArea>
-    <c:plotVisOnly val="1"/>
-    <c:dispBlanksAs val="span"/>
-  </c:chart>
-  <c:spPr>
-    <a:noFill/>
-    <a:ln>
-      <a:noFill/>
-    </a:ln>
-    <a:effectLst/>
-  </c:spPr>
-  <c:externalData r:id="rId1">
-    <c:autoUpdate val="0"/>
-  </c:externalData>
-</c:chartSpace>
-</file>
-
-<file path=ppt/charts/chart2.xml><?xml version="1.0" encoding="utf-8"?>
-<c:chartSpace xmlns:c="http://schemas.openxmlformats.org/drawingml/2006/chart" xmlns:a="http://schemas.openxmlformats.org/drawingml/2006/main" xmlns:r="http://schemas.openxmlformats.org/officeDocument/2006/relationships">
-  <c:date1904 val="0"/>
-  <c:roundedCorners val="1"/>
-  <c:chart>
-    <c:autoTitleDeleted val="1"/>
-    <c:plotArea>
-      <c:layout/>
-      <c:barChart>
-        <c:barDir val="bar"/>
-        <c:grouping val="clustered"/>
-        <c:varyColors val="0"/>
-        <c:ser>
-          <c:idx val="0"/>
-          <c:order val="0"/>
-          <c:tx>
-            <c:strRef>
-              <c:f>Sheet1!$B$1</c:f>
-              <c:strCache>
-                <c:ptCount val="1"/>
-                <c:pt idx="0">
-                  <c:v>citation precision %</c:v>
-                </c:pt>
-              </c:strCache>
-            </c:strRef>
-          </c:tx>
-          <c:spPr>
-            <a:solidFill>
-              <a:srgbClr val="7C9A82"/>
-            </a:solidFill>
-            <a:effectLst/>
-          </c:spPr>
-          <c:invertIfNegative val="0"/>
-          <c:dLbls>
-            <c:numFmt formatCode="0&quot;%&quot;" sourceLinked="0"/>
-            <c:txPr>
-              <a:bodyPr/>
-              <a:lstStyle/>
-              <a:p>
-                <a:pPr>
-                  <a:defRPr b="0" i="0" strike="noStrike" sz="1000" u="none">
-                    <a:solidFill>
-                      <a:srgbClr val="2B2A28"/>
-                    </a:solidFill>
-                    <a:latin typeface="Arial"/>
-                  </a:defRPr>
-                </a:pPr>
-              </a:p>
-            </c:txPr>
-            <c:showLegendKey val="0"/>
-            <c:showVal val="1"/>
-            <c:showCatName val="0"/>
-            <c:showSerName val="0"/>
-            <c:showPercent val="0"/>
-            <c:showBubbleSize val="0"/>
-            <c:showLeaderLines val="0"/>
-          </c:dLbls>
-          <c:dPt>
-            <c:idx val="0"/>
-            <c:invertIfNegative val="0"/>
-            <c:bubble3D val="0"/>
-            <c:spPr>
-              <a:solidFill>
-                <a:srgbClr val="7C9A82"/>
-              </a:solidFill>
-              <a:effectLst/>
-            </c:spPr>
-          </c:dPt>
-          <c:dPt>
-            <c:idx val="1"/>
-            <c:invertIfNegative val="0"/>
-            <c:bubble3D val="0"/>
-            <c:spPr>
-              <a:solidFill>
-                <a:srgbClr val="7C9A82"/>
-              </a:solidFill>
-              <a:effectLst/>
-            </c:spPr>
-          </c:dPt>
-          <c:dPt>
-            <c:idx val="2"/>
-            <c:invertIfNegative val="0"/>
-            <c:bubble3D val="0"/>
-            <c:spPr>
-              <a:solidFill>
-                <a:srgbClr val="D86A2E"/>
-              </a:solidFill>
-              <a:effectLst/>
-            </c:spPr>
-          </c:dPt>
-          <c:dPt>
-            <c:idx val="3"/>
-            <c:invertIfNegative val="0"/>
-            <c:bubble3D val="0"/>
-            <c:spPr>
-              <a:solidFill>
-                <a:srgbClr val="7C9A82"/>
-              </a:solidFill>
-              <a:effectLst/>
-            </c:spPr>
-          </c:dPt>
-          <c:dPt>
-            <c:idx val="4"/>
-            <c:invertIfNegative val="0"/>
-            <c:bubble3D val="0"/>
-            <c:spPr>
-              <a:solidFill>
-                <a:srgbClr val="7C9A82"/>
-              </a:solidFill>
-              <a:effectLst/>
-            </c:spPr>
-          </c:dPt>
-          <c:dPt>
-            <c:idx val="5"/>
-            <c:invertIfNegative val="0"/>
-            <c:bubble3D val="0"/>
-            <c:spPr>
-              <a:solidFill>
-                <a:srgbClr val="7C9A82"/>
-              </a:solidFill>
-              <a:effectLst/>
-            </c:spPr>
-          </c:dPt>
-          <c:dPt>
-            <c:idx val="6"/>
-            <c:invertIfNegative val="0"/>
-            <c:bubble3D val="0"/>
-            <c:spPr>
-              <a:solidFill>
-                <a:srgbClr val="138A72"/>
-              </a:solidFill>
-              <a:effectLst/>
-            </c:spPr>
-          </c:dPt>
-          <c:cat>
-            <c:multiLvlStrRef>
-              <c:f>Sheet1!$A$2:$A$8</c:f>
-              <c:multiLvlStrCache>
-                <c:ptCount val="7"/>
-                <c:lvl>
-                  <c:pt idx="0">
-                    <c:v>Baseline (judge v1)</c:v>
-                  </c:pt>
-                  <c:pt idx="1">
-                    <c:v>gpt-4.1-mini writer</c:v>
-                  </c:pt>
-                  <c:pt idx="2">
-                    <c:v>No reranker</c:v>
-                  </c:pt>
-                  <c:pt idx="3">
-                    <c:v>Single query</c:v>
-                  </c:pt>
-                  <c:pt idx="4">
-                    <c:v>Prompt v1</c:v>
-                  </c:pt>
-                  <c:pt idx="5">
-                    <c:v>No citation loop</c:v>
-                  </c:pt>
-                  <c:pt idx="6">
-                    <c:v>Final (judge v2, mean of 3)</c:v>
-                  </c:pt>
-                </c:lvl>
-              </c:multiLvlStrCache>
-            </c:multiLvlStrRef>
-          </c:cat>
-          <c:val>
-            <c:numRef>
-              <c:f>Sheet1!$B$2:$B$8</c:f>
-              <c:numCache>
-                <c:formatCode>General</c:formatCode>
-                <c:ptCount val="7"/>
-                <c:pt idx="0">
-                  <c:v>78</c:v>
-                </c:pt>
-                <c:pt idx="1">
-                  <c:v>74</c:v>
-                </c:pt>
-                <c:pt idx="2">
-                  <c:v>70</c:v>
-                </c:pt>
-                <c:pt idx="3">
-                  <c:v>80</c:v>
-                </c:pt>
-                <c:pt idx="4">
-                  <c:v>73</c:v>
-                </c:pt>
-                <c:pt idx="5">
-                  <c:v>73</c:v>
-                </c:pt>
-                <c:pt idx="6">
-                  <c:v>94</c:v>
-                </c:pt>
-              </c:numCache>
-            </c:numRef>
-          </c:val>
-        </c:ser>
-        <c:dLbls>
-          <c:numFmt formatCode="0&quot;%&quot;" sourceLinked="0"/>
-          <c:txPr>
-            <a:bodyPr/>
-            <a:lstStyle/>
-            <a:p>
-              <a:pPr>
-                <a:defRPr b="0" i="0" strike="noStrike" sz="1000" u="none">
-                  <a:solidFill>
-                    <a:srgbClr val="2B2A28"/>
-                  </a:solidFill>
-                  <a:latin typeface="Arial"/>
-                </a:defRPr>
-              </a:pPr>
-            </a:p>
-          </c:txPr>
-          <c:showLegendKey val="0"/>
-          <c:showVal val="1"/>
-          <c:showCatName val="0"/>
-          <c:showSerName val="0"/>
-          <c:showPercent val="0"/>
-          <c:showBubbleSize val="0"/>
-          <c:showLeaderLines val="0"/>
-        </c:dLbls>
-        <c:gapWidth val="150"/>
-        <c:overlap val="0"/>
-        <c:axId val="2094734554"/>
-        <c:axId val="2094734552"/>
-        <c:axId val="2094734556"/>
-      </c:barChart>
-      <c:catAx>
-        <c:axId val="2094734554"/>
-        <c:scaling>
-          <c:orientation val="maxMin"/>
-        </c:scaling>
-        <c:delete val="0"/>
-        <c:axPos val="l"/>
-        <c:numFmt formatCode="General" sourceLinked="1"/>
-        <c:majorTickMark val="out"/>
-        <c:minorTickMark val="none"/>
-        <c:tickLblPos val="nextTo"/>
-        <c:spPr>
-          <a:ln w="12700" cap="flat">
-            <a:solidFill>
-              <a:srgbClr val="888888"/>
-            </a:solidFill>
-            <a:prstDash val="solid"/>
-            <a:round/>
-          </a:ln>
-        </c:spPr>
-        <c:txPr>
-          <a:bodyPr/>
-          <a:lstStyle/>
-          <a:p>
-            <a:pPr>
-              <a:defRPr sz="1050" b="0" i="0" u="none" strike="noStrike">
-                <a:solidFill>
-                  <a:srgbClr val="2B2A28"/>
-                </a:solidFill>
-                <a:latin typeface="Arial"/>
-              </a:defRPr>
-            </a:pPr>
-            <a:endParaRPr lang="en-US"/>
-          </a:p>
-        </c:txPr>
-        <c:crossAx val="2094734552"/>
-        <c:crosses val="autoZero"/>
-        <c:auto val="1"/>
-        <c:lblAlgn val="ctr"/>
-        <c:noMultiLvlLbl val="1"/>
-      </c:catAx>
-      <c:valAx>
-        <c:axId val="2094734552"/>
-        <c:scaling>
-          <c:orientation val="minMax"/>
-          <c:max val="100"/>
-          <c:min val="0"/>
-        </c:scaling>
-        <c:delete val="1"/>
-        <c:axPos val="b"/>
-        <c:numFmt formatCode="General" sourceLinked="0"/>
-        <c:majorTickMark val="out"/>
-        <c:minorTickMark val="none"/>
-        <c:tickLblPos val="low"/>
-        <c:spPr>
-          <a:ln w="12700" cap="flat">
-            <a:solidFill>
-              <a:srgbClr val="888888"/>
-            </a:solidFill>
-            <a:prstDash val="solid"/>
-            <a:round/>
-          </a:ln>
-        </c:spPr>
-        <c:txPr>
-          <a:bodyPr/>
-          <a:lstStyle/>
-          <a:p>
-            <a:pPr>
-              <a:defRPr sz="1200" b="0" i="0" u="none" strike="noStrike">
-                <a:solidFill>
-                  <a:srgbClr val="000000"/>
-                </a:solidFill>
-                <a:latin typeface="Arial"/>
-              </a:defRPr>
-            </a:pPr>
-            <a:endParaRPr lang="en-US"/>
-          </a:p>
-        </c:txPr>
-        <c:crossAx val="2094734554"/>
-        <c:crosses val="autoZero"/>
-        <c:crossBetween val="between"/>
-      </c:valAx>
-      <c:spPr>
-        <a:noFill/>
-        <a:ln>
-          <a:noFill/>
-        </a:ln>
-        <a:effectLst/>
-      </c:spPr>
-    </c:plotArea>
-    <c:plotVisOnly val="1"/>
-    <c:dispBlanksAs val="span"/>
-  </c:chart>
-  <c:spPr>
-    <a:noFill/>
-    <a:ln>
-      <a:noFill/>
-    </a:ln>
-    <a:effectLst/>
-  </c:spPr>
-  <c:externalData r:id="rId1">
-    <c:autoUpdate val="0"/>
-  </c:externalData>
-</c:chartSpace>
 </file>
 
 <file path=ppt/notesMasters/notesMaster1.xml><?xml version="1.0" encoding="utf-8"?>
@@ -1398,7 +779,7 @@
           <a:p>
             <a:r>
               <a:rPr lang="en-US" dirty="0"/>
-              <a:t/>
+              <a:t>Live at the defense: open the bloom-production project, click the latest trace from the demo question, expand citation_check, then show the bloom-final experiment.</a:t>
             </a:r>
             <a:endParaRPr lang="en-US" dirty="0"/>
           </a:p>
@@ -1510,6 +891,94 @@
             <a:fld id="{F7021451-1387-4CA6-816F-3879F97B5CBC}" type="slidenum">
               <a:rPr lang="en-US"/>
               <a:t>13</a:t>
+            </a:fld>
+            <a:endParaRPr lang="en-US"/>
+          </a:p>
+        </p:txBody>
+      </p:sp>
+    </p:spTree>
+    <p:extLst>
+      <p:ext uri="{BB962C8B-B14F-4D97-AF65-F5344CB8AC3E}">
+        <p14:creationId xmlns:p14="http://schemas.microsoft.com/office/powerpoint/2010/main" val="1024086991"/>
+      </p:ext>
+    </p:extLst>
+  </p:cSld>
+  <p:clrMapOvr>
+    <a:masterClrMapping/>
+  </p:clrMapOvr>
+</p:notes>
+</file>
+
+<file path=ppt/notesSlides/notesSlide14.xml><?xml version="1.0" encoding="utf-8"?>
+<p:notes xmlns:a="http://schemas.openxmlformats.org/drawingml/2006/main" xmlns:r="http://schemas.openxmlformats.org/officeDocument/2006/relationships" xmlns:p="http://schemas.openxmlformats.org/presentationml/2006/main">
+  <p:cSld>
+    <p:spTree>
+      <p:nvGrpSpPr>
+        <p:cNvPr id="1" name=""/>
+        <p:cNvGrpSpPr/>
+        <p:nvPr/>
+      </p:nvGrpSpPr>
+      <p:grpSpPr>
+        <a:xfrm>
+          <a:off x="0" y="0"/>
+          <a:ext cx="0" cy="0"/>
+          <a:chOff x="0" y="0"/>
+          <a:chExt cx="0" cy="0"/>
+        </a:xfrm>
+      </p:grpSpPr>
+      <p:sp>
+        <p:nvSpPr>
+          <p:cNvPr id="2" name="Slide Image Placeholder 1"/>
+          <p:cNvSpPr>
+            <a:spLocks noGrp="1" noRot="1" noChangeAspect="1"/>
+          </p:cNvSpPr>
+          <p:nvPr>
+            <p:ph type="sldImg"/>
+          </p:nvPr>
+        </p:nvSpPr>
+        <p:spPr/>
+      </p:sp>
+      <p:sp>
+        <p:nvSpPr>
+          <p:cNvPr id="3" name="Notes Placeholder 2"/>
+          <p:cNvSpPr>
+            <a:spLocks noGrp="1"/>
+          </p:cNvSpPr>
+          <p:nvPr>
+            <p:ph type="body" idx="1"/>
+          </p:nvPr>
+        </p:nvSpPr>
+        <p:spPr/>
+        <p:txBody>
+          <a:bodyPr/>
+          <a:lstStyle/>
+          <a:p>
+            <a:r>
+              <a:rPr lang="en-US" dirty="0"/>
+              <a:t/>
+            </a:r>
+            <a:endParaRPr lang="en-US" dirty="0"/>
+          </a:p>
+        </p:txBody>
+      </p:sp>
+      <p:sp>
+        <p:nvSpPr>
+          <p:cNvPr id="4" name="Slide Number Placeholder 3"/>
+          <p:cNvSpPr>
+            <a:spLocks noGrp="1"/>
+          </p:cNvSpPr>
+          <p:nvPr>
+            <p:ph type="sldNum" sz="quarter" idx="10"/>
+          </p:nvPr>
+        </p:nvSpPr>
+        <p:spPr/>
+        <p:txBody>
+          <a:bodyPr/>
+          <a:lstStyle/>
+          <a:p>
+            <a:fld id="{F7021451-1387-4CA6-816F-3879F97B5CBC}" type="slidenum">
+              <a:rPr lang="en-US"/>
+              <a:t>14</a:t>
             </a:fld>
             <a:endParaRPr lang="en-US"/>
           </a:p>
@@ -2895,22 +2364,829 @@
           </a:p>
         </p:txBody>
       </p:sp>
-      <p:graphicFrame>
-        <p:nvGraphicFramePr>
-          <p:cNvPr id="4" name="Chart 0" descr=""/>
-          <p:cNvGraphicFramePr/>
-          <p:nvPr/>
-        </p:nvGraphicFramePr>
-        <p:xfrm>
-          <a:off x="365760" y="1234440"/>
-          <a:ext cx="4206240" cy="3383280"/>
-        </p:xfrm>
-        <a:graphic xmlns:a="http://schemas.openxmlformats.org/drawingml/2006/main">
-          <a:graphicData uri="http://schemas.openxmlformats.org/drawingml/2006/chart">
-            <c:chart xmlns:c="http://schemas.openxmlformats.org/drawingml/2006/chart" r:id="rId1"/>
-          </a:graphicData>
-        </a:graphic>
-      </p:graphicFrame>
+      <p:sp>
+        <p:nvSpPr>
+          <p:cNvPr id="4" name="Text 2"/>
+          <p:cNvSpPr txBox="1"/>
+          <p:nvPr/>
+        </p:nvSpPr>
+        <p:spPr>
+          <a:xfrm>
+            <a:off x="457200" y="1325880"/>
+            <a:ext cx="4023360" cy="274320"/>
+          </a:xfrm>
+          <a:prstGeom prst="rect">
+            <a:avLst/>
+          </a:prstGeom>
+          <a:noFill/>
+          <a:ln/>
+        </p:spPr>
+        <p:txBody>
+          <a:bodyPr wrap="square" lIns="0" tIns="0" rIns="0" bIns="0" rtlCol="0" anchor="ctr"/>
+          <a:lstStyle/>
+          <a:p>
+            <a:pPr indent="0" marL="0">
+              <a:buNone/>
+            </a:pPr>
+            <a:r>
+              <a:rPr lang="en-US" sz="1200" b="1" dirty="0">
+                <a:solidFill>
+                  <a:srgbClr val="2B2A28"/>
+                </a:solidFill>
+                <a:latin typeface="Calibri" pitchFamily="34" charset="0"/>
+                <a:ea typeface="Calibri" pitchFamily="34" charset="-122"/>
+                <a:cs typeface="Calibri" pitchFamily="34" charset="-120"/>
+              </a:rPr>
+              <a:t>Golden set by category</a:t>
+            </a:r>
+            <a:endParaRPr lang="en-US" sz="1200" dirty="0"/>
+          </a:p>
+        </p:txBody>
+      </p:sp>
+      <p:sp>
+        <p:nvSpPr>
+          <p:cNvPr id="5" name="Text 3"/>
+          <p:cNvSpPr txBox="1"/>
+          <p:nvPr/>
+        </p:nvSpPr>
+        <p:spPr>
+          <a:xfrm>
+            <a:off x="457200" y="1691640"/>
+            <a:ext cx="1598371" cy="354330"/>
+          </a:xfrm>
+          <a:prstGeom prst="rect">
+            <a:avLst/>
+          </a:prstGeom>
+          <a:noFill/>
+          <a:ln/>
+        </p:spPr>
+        <p:txBody>
+          <a:bodyPr wrap="square" lIns="0" tIns="0" rIns="0" bIns="0" rtlCol="0" anchor="ctr"/>
+          <a:lstStyle/>
+          <a:p>
+            <a:pPr algn="r" indent="0" marL="0">
+              <a:buNone/>
+            </a:pPr>
+            <a:r>
+              <a:rPr lang="en-US" sz="1050" dirty="0">
+                <a:solidFill>
+                  <a:srgbClr val="2B2A28"/>
+                </a:solidFill>
+                <a:latin typeface="Calibri" pitchFamily="34" charset="0"/>
+                <a:ea typeface="Calibri" pitchFamily="34" charset="-122"/>
+                <a:cs typeface="Calibri" pitchFamily="34" charset="-120"/>
+              </a:rPr>
+              <a:t>evidence</a:t>
+            </a:r>
+            <a:endParaRPr lang="en-US" sz="1050" dirty="0"/>
+          </a:p>
+        </p:txBody>
+      </p:sp>
+      <p:sp>
+        <p:nvSpPr>
+          <p:cNvPr id="6" name="Shape 4"/>
+          <p:cNvSpPr/>
+          <p:nvPr/>
+        </p:nvSpPr>
+        <p:spPr>
+          <a:xfrm>
+            <a:off x="2147011" y="1758963"/>
+            <a:ext cx="1830629" cy="219685"/>
+          </a:xfrm>
+          <a:prstGeom prst="rect">
+            <a:avLst/>
+          </a:prstGeom>
+          <a:solidFill>
+            <a:srgbClr val="138A72"/>
+          </a:solidFill>
+          <a:ln/>
+        </p:spPr>
+      </p:sp>
+      <p:sp>
+        <p:nvSpPr>
+          <p:cNvPr id="7" name="Text 5"/>
+          <p:cNvSpPr txBox="1"/>
+          <p:nvPr/>
+        </p:nvSpPr>
+        <p:spPr>
+          <a:xfrm>
+            <a:off x="4032504" y="1691640"/>
+            <a:ext cx="457200" cy="354330"/>
+          </a:xfrm>
+          <a:prstGeom prst="rect">
+            <a:avLst/>
+          </a:prstGeom>
+          <a:noFill/>
+          <a:ln/>
+        </p:spPr>
+        <p:txBody>
+          <a:bodyPr wrap="square" lIns="0" tIns="0" rIns="0" bIns="0" rtlCol="0" anchor="ctr"/>
+          <a:lstStyle/>
+          <a:p>
+            <a:pPr indent="0" marL="0">
+              <a:buNone/>
+            </a:pPr>
+            <a:r>
+              <a:rPr lang="en-US" sz="1000" b="1" dirty="0">
+                <a:solidFill>
+                  <a:srgbClr val="2B2A28"/>
+                </a:solidFill>
+                <a:latin typeface="Calibri" pitchFamily="34" charset="0"/>
+                <a:ea typeface="Calibri" pitchFamily="34" charset="-122"/>
+                <a:cs typeface="Calibri" pitchFamily="34" charset="-120"/>
+              </a:rPr>
+              <a:t>14</a:t>
+            </a:r>
+            <a:endParaRPr lang="en-US" sz="1000" dirty="0"/>
+          </a:p>
+        </p:txBody>
+      </p:sp>
+      <p:sp>
+        <p:nvSpPr>
+          <p:cNvPr id="8" name="Text 6"/>
+          <p:cNvSpPr txBox="1"/>
+          <p:nvPr/>
+        </p:nvSpPr>
+        <p:spPr>
+          <a:xfrm>
+            <a:off x="457200" y="2045970"/>
+            <a:ext cx="1598371" cy="354330"/>
+          </a:xfrm>
+          <a:prstGeom prst="rect">
+            <a:avLst/>
+          </a:prstGeom>
+          <a:noFill/>
+          <a:ln/>
+        </p:spPr>
+        <p:txBody>
+          <a:bodyPr wrap="square" lIns="0" tIns="0" rIns="0" bIns="0" rtlCol="0" anchor="ctr"/>
+          <a:lstStyle/>
+          <a:p>
+            <a:pPr algn="r" indent="0" marL="0">
+              <a:buNone/>
+            </a:pPr>
+            <a:r>
+              <a:rPr lang="en-US" sz="1050" dirty="0">
+                <a:solidFill>
+                  <a:srgbClr val="2B2A28"/>
+                </a:solidFill>
+                <a:latin typeface="Calibri" pitchFamily="34" charset="0"/>
+                <a:ea typeface="Calibri" pitchFamily="34" charset="-122"/>
+                <a:cs typeface="Calibri" pitchFamily="34" charset="-120"/>
+              </a:rPr>
+              <a:t>data</a:t>
+            </a:r>
+            <a:endParaRPr lang="en-US" sz="1050" dirty="0"/>
+          </a:p>
+        </p:txBody>
+      </p:sp>
+      <p:sp>
+        <p:nvSpPr>
+          <p:cNvPr id="9" name="Shape 7"/>
+          <p:cNvSpPr/>
+          <p:nvPr/>
+        </p:nvSpPr>
+        <p:spPr>
+          <a:xfrm>
+            <a:off x="2147011" y="2113293"/>
+            <a:ext cx="1176833" cy="219685"/>
+          </a:xfrm>
+          <a:prstGeom prst="rect">
+            <a:avLst/>
+          </a:prstGeom>
+          <a:solidFill>
+            <a:srgbClr val="138A72"/>
+          </a:solidFill>
+          <a:ln/>
+        </p:spPr>
+      </p:sp>
+      <p:sp>
+        <p:nvSpPr>
+          <p:cNvPr id="10" name="Text 8"/>
+          <p:cNvSpPr txBox="1"/>
+          <p:nvPr/>
+        </p:nvSpPr>
+        <p:spPr>
+          <a:xfrm>
+            <a:off x="3378708" y="2045970"/>
+            <a:ext cx="457200" cy="354330"/>
+          </a:xfrm>
+          <a:prstGeom prst="rect">
+            <a:avLst/>
+          </a:prstGeom>
+          <a:noFill/>
+          <a:ln/>
+        </p:spPr>
+        <p:txBody>
+          <a:bodyPr wrap="square" lIns="0" tIns="0" rIns="0" bIns="0" rtlCol="0" anchor="ctr"/>
+          <a:lstStyle/>
+          <a:p>
+            <a:pPr indent="0" marL="0">
+              <a:buNone/>
+            </a:pPr>
+            <a:r>
+              <a:rPr lang="en-US" sz="1000" b="1" dirty="0">
+                <a:solidFill>
+                  <a:srgbClr val="2B2A28"/>
+                </a:solidFill>
+                <a:latin typeface="Calibri" pitchFamily="34" charset="0"/>
+                <a:ea typeface="Calibri" pitchFamily="34" charset="-122"/>
+                <a:cs typeface="Calibri" pitchFamily="34" charset="-120"/>
+              </a:rPr>
+              <a:t>9</a:t>
+            </a:r>
+            <a:endParaRPr lang="en-US" sz="1000" dirty="0"/>
+          </a:p>
+        </p:txBody>
+      </p:sp>
+      <p:sp>
+        <p:nvSpPr>
+          <p:cNvPr id="11" name="Text 9"/>
+          <p:cNvSpPr txBox="1"/>
+          <p:nvPr/>
+        </p:nvSpPr>
+        <p:spPr>
+          <a:xfrm>
+            <a:off x="457200" y="2400300"/>
+            <a:ext cx="1598371" cy="354330"/>
+          </a:xfrm>
+          <a:prstGeom prst="rect">
+            <a:avLst/>
+          </a:prstGeom>
+          <a:noFill/>
+          <a:ln/>
+        </p:spPr>
+        <p:txBody>
+          <a:bodyPr wrap="square" lIns="0" tIns="0" rIns="0" bIns="0" rtlCol="0" anchor="ctr"/>
+          <a:lstStyle/>
+          <a:p>
+            <a:pPr algn="r" indent="0" marL="0">
+              <a:buNone/>
+            </a:pPr>
+            <a:r>
+              <a:rPr lang="en-US" sz="1050" dirty="0">
+                <a:solidFill>
+                  <a:srgbClr val="2B2A28"/>
+                </a:solidFill>
+                <a:latin typeface="Calibri" pitchFamily="34" charset="0"/>
+                <a:ea typeface="Calibri" pitchFamily="34" charset="-122"/>
+                <a:cs typeface="Calibri" pitchFamily="34" charset="-120"/>
+              </a:rPr>
+              <a:t>red flag</a:t>
+            </a:r>
+            <a:endParaRPr lang="en-US" sz="1050" dirty="0"/>
+          </a:p>
+        </p:txBody>
+      </p:sp>
+      <p:sp>
+        <p:nvSpPr>
+          <p:cNvPr id="12" name="Shape 10"/>
+          <p:cNvSpPr/>
+          <p:nvPr/>
+        </p:nvSpPr>
+        <p:spPr>
+          <a:xfrm>
+            <a:off x="2147011" y="2467623"/>
+            <a:ext cx="1046074" cy="219685"/>
+          </a:xfrm>
+          <a:prstGeom prst="rect">
+            <a:avLst/>
+          </a:prstGeom>
+          <a:solidFill>
+            <a:srgbClr val="138A72"/>
+          </a:solidFill>
+          <a:ln/>
+        </p:spPr>
+      </p:sp>
+      <p:sp>
+        <p:nvSpPr>
+          <p:cNvPr id="13" name="Text 11"/>
+          <p:cNvSpPr txBox="1"/>
+          <p:nvPr/>
+        </p:nvSpPr>
+        <p:spPr>
+          <a:xfrm>
+            <a:off x="3247949" y="2400300"/>
+            <a:ext cx="457200" cy="354330"/>
+          </a:xfrm>
+          <a:prstGeom prst="rect">
+            <a:avLst/>
+          </a:prstGeom>
+          <a:noFill/>
+          <a:ln/>
+        </p:spPr>
+        <p:txBody>
+          <a:bodyPr wrap="square" lIns="0" tIns="0" rIns="0" bIns="0" rtlCol="0" anchor="ctr"/>
+          <a:lstStyle/>
+          <a:p>
+            <a:pPr indent="0" marL="0">
+              <a:buNone/>
+            </a:pPr>
+            <a:r>
+              <a:rPr lang="en-US" sz="1000" b="1" dirty="0">
+                <a:solidFill>
+                  <a:srgbClr val="2B2A28"/>
+                </a:solidFill>
+                <a:latin typeface="Calibri" pitchFamily="34" charset="0"/>
+                <a:ea typeface="Calibri" pitchFamily="34" charset="-122"/>
+                <a:cs typeface="Calibri" pitchFamily="34" charset="-120"/>
+              </a:rPr>
+              <a:t>8</a:t>
+            </a:r>
+            <a:endParaRPr lang="en-US" sz="1000" dirty="0"/>
+          </a:p>
+        </p:txBody>
+      </p:sp>
+      <p:sp>
+        <p:nvSpPr>
+          <p:cNvPr id="14" name="Text 12"/>
+          <p:cNvSpPr txBox="1"/>
+          <p:nvPr/>
+        </p:nvSpPr>
+        <p:spPr>
+          <a:xfrm>
+            <a:off x="457200" y="2754630"/>
+            <a:ext cx="1598371" cy="354330"/>
+          </a:xfrm>
+          <a:prstGeom prst="rect">
+            <a:avLst/>
+          </a:prstGeom>
+          <a:noFill/>
+          <a:ln/>
+        </p:spPr>
+        <p:txBody>
+          <a:bodyPr wrap="square" lIns="0" tIns="0" rIns="0" bIns="0" rtlCol="0" anchor="ctr"/>
+          <a:lstStyle/>
+          <a:p>
+            <a:pPr algn="r" indent="0" marL="0">
+              <a:buNone/>
+            </a:pPr>
+            <a:r>
+              <a:rPr lang="en-US" sz="1050" dirty="0">
+                <a:solidFill>
+                  <a:srgbClr val="2B2A28"/>
+                </a:solidFill>
+                <a:latin typeface="Calibri" pitchFamily="34" charset="0"/>
+                <a:ea typeface="Calibri" pitchFamily="34" charset="-122"/>
+                <a:cs typeface="Calibri" pitchFamily="34" charset="-120"/>
+              </a:rPr>
+              <a:t>near miss</a:t>
+            </a:r>
+            <a:endParaRPr lang="en-US" sz="1050" dirty="0"/>
+          </a:p>
+        </p:txBody>
+      </p:sp>
+      <p:sp>
+        <p:nvSpPr>
+          <p:cNvPr id="15" name="Shape 13"/>
+          <p:cNvSpPr/>
+          <p:nvPr/>
+        </p:nvSpPr>
+        <p:spPr>
+          <a:xfrm>
+            <a:off x="2147011" y="2821953"/>
+            <a:ext cx="523037" cy="219685"/>
+          </a:xfrm>
+          <a:prstGeom prst="rect">
+            <a:avLst/>
+          </a:prstGeom>
+          <a:solidFill>
+            <a:srgbClr val="138A72"/>
+          </a:solidFill>
+          <a:ln/>
+        </p:spPr>
+      </p:sp>
+      <p:sp>
+        <p:nvSpPr>
+          <p:cNvPr id="16" name="Text 14"/>
+          <p:cNvSpPr txBox="1"/>
+          <p:nvPr/>
+        </p:nvSpPr>
+        <p:spPr>
+          <a:xfrm>
+            <a:off x="2724912" y="2754630"/>
+            <a:ext cx="457200" cy="354330"/>
+          </a:xfrm>
+          <a:prstGeom prst="rect">
+            <a:avLst/>
+          </a:prstGeom>
+          <a:noFill/>
+          <a:ln/>
+        </p:spPr>
+        <p:txBody>
+          <a:bodyPr wrap="square" lIns="0" tIns="0" rIns="0" bIns="0" rtlCol="0" anchor="ctr"/>
+          <a:lstStyle/>
+          <a:p>
+            <a:pPr indent="0" marL="0">
+              <a:buNone/>
+            </a:pPr>
+            <a:r>
+              <a:rPr lang="en-US" sz="1000" b="1" dirty="0">
+                <a:solidFill>
+                  <a:srgbClr val="2B2A28"/>
+                </a:solidFill>
+                <a:latin typeface="Calibri" pitchFamily="34" charset="0"/>
+                <a:ea typeface="Calibri" pitchFamily="34" charset="-122"/>
+                <a:cs typeface="Calibri" pitchFamily="34" charset="-120"/>
+              </a:rPr>
+              <a:t>4</a:t>
+            </a:r>
+            <a:endParaRPr lang="en-US" sz="1000" dirty="0"/>
+          </a:p>
+        </p:txBody>
+      </p:sp>
+      <p:sp>
+        <p:nvSpPr>
+          <p:cNvPr id="17" name="Text 15"/>
+          <p:cNvSpPr txBox="1"/>
+          <p:nvPr/>
+        </p:nvSpPr>
+        <p:spPr>
+          <a:xfrm>
+            <a:off x="457200" y="3108960"/>
+            <a:ext cx="1598371" cy="354330"/>
+          </a:xfrm>
+          <a:prstGeom prst="rect">
+            <a:avLst/>
+          </a:prstGeom>
+          <a:noFill/>
+          <a:ln/>
+        </p:spPr>
+        <p:txBody>
+          <a:bodyPr wrap="square" lIns="0" tIns="0" rIns="0" bIns="0" rtlCol="0" anchor="ctr"/>
+          <a:lstStyle/>
+          <a:p>
+            <a:pPr algn="r" indent="0" marL="0">
+              <a:buNone/>
+            </a:pPr>
+            <a:r>
+              <a:rPr lang="en-US" sz="1050" dirty="0">
+                <a:solidFill>
+                  <a:srgbClr val="2B2A28"/>
+                </a:solidFill>
+                <a:latin typeface="Calibri" pitchFamily="34" charset="0"/>
+                <a:ea typeface="Calibri" pitchFamily="34" charset="-122"/>
+                <a:cs typeface="Calibri" pitchFamily="34" charset="-120"/>
+              </a:rPr>
+              <a:t>injection</a:t>
+            </a:r>
+            <a:endParaRPr lang="en-US" sz="1050" dirty="0"/>
+          </a:p>
+        </p:txBody>
+      </p:sp>
+      <p:sp>
+        <p:nvSpPr>
+          <p:cNvPr id="18" name="Shape 16"/>
+          <p:cNvSpPr/>
+          <p:nvPr/>
+        </p:nvSpPr>
+        <p:spPr>
+          <a:xfrm>
+            <a:off x="2147011" y="3176283"/>
+            <a:ext cx="261518" cy="219685"/>
+          </a:xfrm>
+          <a:prstGeom prst="rect">
+            <a:avLst/>
+          </a:prstGeom>
+          <a:solidFill>
+            <a:srgbClr val="138A72"/>
+          </a:solidFill>
+          <a:ln/>
+        </p:spPr>
+      </p:sp>
+      <p:sp>
+        <p:nvSpPr>
+          <p:cNvPr id="19" name="Text 17"/>
+          <p:cNvSpPr txBox="1"/>
+          <p:nvPr/>
+        </p:nvSpPr>
+        <p:spPr>
+          <a:xfrm>
+            <a:off x="2463394" y="3108960"/>
+            <a:ext cx="457200" cy="354330"/>
+          </a:xfrm>
+          <a:prstGeom prst="rect">
+            <a:avLst/>
+          </a:prstGeom>
+          <a:noFill/>
+          <a:ln/>
+        </p:spPr>
+        <p:txBody>
+          <a:bodyPr wrap="square" lIns="0" tIns="0" rIns="0" bIns="0" rtlCol="0" anchor="ctr"/>
+          <a:lstStyle/>
+          <a:p>
+            <a:pPr indent="0" marL="0">
+              <a:buNone/>
+            </a:pPr>
+            <a:r>
+              <a:rPr lang="en-US" sz="1000" b="1" dirty="0">
+                <a:solidFill>
+                  <a:srgbClr val="2B2A28"/>
+                </a:solidFill>
+                <a:latin typeface="Calibri" pitchFamily="34" charset="0"/>
+                <a:ea typeface="Calibri" pitchFamily="34" charset="-122"/>
+                <a:cs typeface="Calibri" pitchFamily="34" charset="-120"/>
+              </a:rPr>
+              <a:t>2</a:t>
+            </a:r>
+            <a:endParaRPr lang="en-US" sz="1000" dirty="0"/>
+          </a:p>
+        </p:txBody>
+      </p:sp>
+      <p:sp>
+        <p:nvSpPr>
+          <p:cNvPr id="20" name="Text 18"/>
+          <p:cNvSpPr txBox="1"/>
+          <p:nvPr/>
+        </p:nvSpPr>
+        <p:spPr>
+          <a:xfrm>
+            <a:off x="457200" y="3463290"/>
+            <a:ext cx="1598371" cy="354330"/>
+          </a:xfrm>
+          <a:prstGeom prst="rect">
+            <a:avLst/>
+          </a:prstGeom>
+          <a:noFill/>
+          <a:ln/>
+        </p:spPr>
+        <p:txBody>
+          <a:bodyPr wrap="square" lIns="0" tIns="0" rIns="0" bIns="0" rtlCol="0" anchor="ctr"/>
+          <a:lstStyle/>
+          <a:p>
+            <a:pPr algn="r" indent="0" marL="0">
+              <a:buNone/>
+            </a:pPr>
+            <a:r>
+              <a:rPr lang="en-US" sz="1050" dirty="0">
+                <a:solidFill>
+                  <a:srgbClr val="2B2A28"/>
+                </a:solidFill>
+                <a:latin typeface="Calibri" pitchFamily="34" charset="0"/>
+                <a:ea typeface="Calibri" pitchFamily="34" charset="-122"/>
+                <a:cs typeface="Calibri" pitchFamily="34" charset="-120"/>
+              </a:rPr>
+              <a:t>off topic</a:t>
+            </a:r>
+            <a:endParaRPr lang="en-US" sz="1050" dirty="0"/>
+          </a:p>
+        </p:txBody>
+      </p:sp>
+      <p:sp>
+        <p:nvSpPr>
+          <p:cNvPr id="21" name="Shape 19"/>
+          <p:cNvSpPr/>
+          <p:nvPr/>
+        </p:nvSpPr>
+        <p:spPr>
+          <a:xfrm>
+            <a:off x="2147011" y="3530613"/>
+            <a:ext cx="261518" cy="219685"/>
+          </a:xfrm>
+          <a:prstGeom prst="rect">
+            <a:avLst/>
+          </a:prstGeom>
+          <a:solidFill>
+            <a:srgbClr val="138A72"/>
+          </a:solidFill>
+          <a:ln/>
+        </p:spPr>
+      </p:sp>
+      <p:sp>
+        <p:nvSpPr>
+          <p:cNvPr id="22" name="Text 20"/>
+          <p:cNvSpPr txBox="1"/>
+          <p:nvPr/>
+        </p:nvSpPr>
+        <p:spPr>
+          <a:xfrm>
+            <a:off x="2463394" y="3463290"/>
+            <a:ext cx="457200" cy="354330"/>
+          </a:xfrm>
+          <a:prstGeom prst="rect">
+            <a:avLst/>
+          </a:prstGeom>
+          <a:noFill/>
+          <a:ln/>
+        </p:spPr>
+        <p:txBody>
+          <a:bodyPr wrap="square" lIns="0" tIns="0" rIns="0" bIns="0" rtlCol="0" anchor="ctr"/>
+          <a:lstStyle/>
+          <a:p>
+            <a:pPr indent="0" marL="0">
+              <a:buNone/>
+            </a:pPr>
+            <a:r>
+              <a:rPr lang="en-US" sz="1000" b="1" dirty="0">
+                <a:solidFill>
+                  <a:srgbClr val="2B2A28"/>
+                </a:solidFill>
+                <a:latin typeface="Calibri" pitchFamily="34" charset="0"/>
+                <a:ea typeface="Calibri" pitchFamily="34" charset="-122"/>
+                <a:cs typeface="Calibri" pitchFamily="34" charset="-120"/>
+              </a:rPr>
+              <a:t>2</a:t>
+            </a:r>
+            <a:endParaRPr lang="en-US" sz="1000" dirty="0"/>
+          </a:p>
+        </p:txBody>
+      </p:sp>
+      <p:sp>
+        <p:nvSpPr>
+          <p:cNvPr id="23" name="Text 21"/>
+          <p:cNvSpPr txBox="1"/>
+          <p:nvPr/>
+        </p:nvSpPr>
+        <p:spPr>
+          <a:xfrm>
+            <a:off x="457200" y="3817620"/>
+            <a:ext cx="1598371" cy="354330"/>
+          </a:xfrm>
+          <a:prstGeom prst="rect">
+            <a:avLst/>
+          </a:prstGeom>
+          <a:noFill/>
+          <a:ln/>
+        </p:spPr>
+        <p:txBody>
+          <a:bodyPr wrap="square" lIns="0" tIns="0" rIns="0" bIns="0" rtlCol="0" anchor="ctr"/>
+          <a:lstStyle/>
+          <a:p>
+            <a:pPr algn="r" indent="0" marL="0">
+              <a:buNone/>
+            </a:pPr>
+            <a:r>
+              <a:rPr lang="en-US" sz="1050" dirty="0">
+                <a:solidFill>
+                  <a:srgbClr val="2B2A28"/>
+                </a:solidFill>
+                <a:latin typeface="Calibri" pitchFamily="34" charset="0"/>
+                <a:ea typeface="Calibri" pitchFamily="34" charset="-122"/>
+                <a:cs typeface="Calibri" pitchFamily="34" charset="-120"/>
+              </a:rPr>
+              <a:t>smalltalk</a:t>
+            </a:r>
+            <a:endParaRPr lang="en-US" sz="1050" dirty="0"/>
+          </a:p>
+        </p:txBody>
+      </p:sp>
+      <p:sp>
+        <p:nvSpPr>
+          <p:cNvPr id="24" name="Shape 22"/>
+          <p:cNvSpPr/>
+          <p:nvPr/>
+        </p:nvSpPr>
+        <p:spPr>
+          <a:xfrm>
+            <a:off x="2147011" y="3884943"/>
+            <a:ext cx="130759" cy="219685"/>
+          </a:xfrm>
+          <a:prstGeom prst="rect">
+            <a:avLst/>
+          </a:prstGeom>
+          <a:solidFill>
+            <a:srgbClr val="138A72"/>
+          </a:solidFill>
+          <a:ln/>
+        </p:spPr>
+      </p:sp>
+      <p:sp>
+        <p:nvSpPr>
+          <p:cNvPr id="25" name="Text 23"/>
+          <p:cNvSpPr txBox="1"/>
+          <p:nvPr/>
+        </p:nvSpPr>
+        <p:spPr>
+          <a:xfrm>
+            <a:off x="2332634" y="3817620"/>
+            <a:ext cx="457200" cy="354330"/>
+          </a:xfrm>
+          <a:prstGeom prst="rect">
+            <a:avLst/>
+          </a:prstGeom>
+          <a:noFill/>
+          <a:ln/>
+        </p:spPr>
+        <p:txBody>
+          <a:bodyPr wrap="square" lIns="0" tIns="0" rIns="0" bIns="0" rtlCol="0" anchor="ctr"/>
+          <a:lstStyle/>
+          <a:p>
+            <a:pPr indent="0" marL="0">
+              <a:buNone/>
+            </a:pPr>
+            <a:r>
+              <a:rPr lang="en-US" sz="1000" b="1" dirty="0">
+                <a:solidFill>
+                  <a:srgbClr val="2B2A28"/>
+                </a:solidFill>
+                <a:latin typeface="Calibri" pitchFamily="34" charset="0"/>
+                <a:ea typeface="Calibri" pitchFamily="34" charset="-122"/>
+                <a:cs typeface="Calibri" pitchFamily="34" charset="-120"/>
+              </a:rPr>
+              <a:t>1</a:t>
+            </a:r>
+            <a:endParaRPr lang="en-US" sz="1000" dirty="0"/>
+          </a:p>
+        </p:txBody>
+      </p:sp>
+      <p:sp>
+        <p:nvSpPr>
+          <p:cNvPr id="26" name="Text 24"/>
+          <p:cNvSpPr txBox="1"/>
+          <p:nvPr/>
+        </p:nvSpPr>
+        <p:spPr>
+          <a:xfrm>
+            <a:off x="457200" y="4171950"/>
+            <a:ext cx="1598371" cy="354330"/>
+          </a:xfrm>
+          <a:prstGeom prst="rect">
+            <a:avLst/>
+          </a:prstGeom>
+          <a:noFill/>
+          <a:ln/>
+        </p:spPr>
+        <p:txBody>
+          <a:bodyPr wrap="square" lIns="0" tIns="0" rIns="0" bIns="0" rtlCol="0" anchor="ctr"/>
+          <a:lstStyle/>
+          <a:p>
+            <a:pPr algn="r" indent="0" marL="0">
+              <a:buNone/>
+            </a:pPr>
+            <a:r>
+              <a:rPr lang="en-US" sz="1050" dirty="0">
+                <a:solidFill>
+                  <a:srgbClr val="2B2A28"/>
+                </a:solidFill>
+                <a:latin typeface="Calibri" pitchFamily="34" charset="0"/>
+                <a:ea typeface="Calibri" pitchFamily="34" charset="-122"/>
+                <a:cs typeface="Calibri" pitchFamily="34" charset="-120"/>
+              </a:rPr>
+              <a:t>goal</a:t>
+            </a:r>
+            <a:endParaRPr lang="en-US" sz="1050" dirty="0"/>
+          </a:p>
+        </p:txBody>
+      </p:sp>
+      <p:sp>
+        <p:nvSpPr>
+          <p:cNvPr id="27" name="Shape 25"/>
+          <p:cNvSpPr/>
+          <p:nvPr/>
+        </p:nvSpPr>
+        <p:spPr>
+          <a:xfrm>
+            <a:off x="2147011" y="4239273"/>
+            <a:ext cx="392278" cy="219685"/>
+          </a:xfrm>
+          <a:prstGeom prst="rect">
+            <a:avLst/>
+          </a:prstGeom>
+          <a:solidFill>
+            <a:srgbClr val="138A72"/>
+          </a:solidFill>
+          <a:ln/>
+        </p:spPr>
+      </p:sp>
+      <p:sp>
+        <p:nvSpPr>
+          <p:cNvPr id="28" name="Text 26"/>
+          <p:cNvSpPr txBox="1"/>
+          <p:nvPr/>
+        </p:nvSpPr>
+        <p:spPr>
+          <a:xfrm>
+            <a:off x="2594153" y="4171950"/>
+            <a:ext cx="457200" cy="354330"/>
+          </a:xfrm>
+          <a:prstGeom prst="rect">
+            <a:avLst/>
+          </a:prstGeom>
+          <a:noFill/>
+          <a:ln/>
+        </p:spPr>
+        <p:txBody>
+          <a:bodyPr wrap="square" lIns="0" tIns="0" rIns="0" bIns="0" rtlCol="0" anchor="ctr"/>
+          <a:lstStyle/>
+          <a:p>
+            <a:pPr indent="0" marL="0">
+              <a:buNone/>
+            </a:pPr>
+            <a:r>
+              <a:rPr lang="en-US" sz="1000" b="1" dirty="0">
+                <a:solidFill>
+                  <a:srgbClr val="2B2A28"/>
+                </a:solidFill>
+                <a:latin typeface="Calibri" pitchFamily="34" charset="0"/>
+                <a:ea typeface="Calibri" pitchFamily="34" charset="-122"/>
+                <a:cs typeface="Calibri" pitchFamily="34" charset="-120"/>
+              </a:rPr>
+              <a:t>3</a:t>
+            </a:r>
+            <a:endParaRPr lang="en-US" sz="1000" dirty="0"/>
+          </a:p>
+        </p:txBody>
+      </p:sp>
       <p:graphicFrame>
         <p:nvGraphicFramePr>
           <p:cNvPr id="11" name="Table 0"/>
@@ -4592,7 +4868,7 @@
       </p:graphicFrame>
       <p:sp>
         <p:nvSpPr>
-          <p:cNvPr id="6" name="Text 2"/>
+          <p:cNvPr id="30" name="Text 27"/>
           <p:cNvSpPr txBox="1"/>
           <p:nvPr/>
         </p:nvSpPr>
@@ -4739,25 +5015,734 @@
           </a:p>
         </p:txBody>
       </p:sp>
-      <p:graphicFrame>
-        <p:nvGraphicFramePr>
-          <p:cNvPr id="4" name="Chart 0" descr=""/>
-          <p:cNvGraphicFramePr/>
-          <p:nvPr/>
-        </p:nvGraphicFramePr>
-        <p:xfrm>
-          <a:off x="365760" y="1188720"/>
-          <a:ext cx="4846320" cy="3474720"/>
-        </p:xfrm>
-        <a:graphic xmlns:a="http://schemas.openxmlformats.org/drawingml/2006/main">
-          <a:graphicData uri="http://schemas.openxmlformats.org/drawingml/2006/chart">
-            <c:chart xmlns:c="http://schemas.openxmlformats.org/drawingml/2006/chart" r:id="rId1"/>
-          </a:graphicData>
-        </a:graphic>
-      </p:graphicFrame>
-      <p:sp>
-        <p:nvSpPr>
-          <p:cNvPr id="5" name="Text 2"/>
+      <p:sp>
+        <p:nvSpPr>
+          <p:cNvPr id="4" name="Text 2"/>
+          <p:cNvSpPr txBox="1"/>
+          <p:nvPr/>
+        </p:nvSpPr>
+        <p:spPr>
+          <a:xfrm>
+            <a:off x="457200" y="1280160"/>
+            <a:ext cx="4754880" cy="274320"/>
+          </a:xfrm>
+          <a:prstGeom prst="rect">
+            <a:avLst/>
+          </a:prstGeom>
+          <a:noFill/>
+          <a:ln/>
+        </p:spPr>
+        <p:txBody>
+          <a:bodyPr wrap="square" lIns="0" tIns="0" rIns="0" bIns="0" rtlCol="0" anchor="ctr"/>
+          <a:lstStyle/>
+          <a:p>
+            <a:pPr indent="0" marL="0">
+              <a:buNone/>
+            </a:pPr>
+            <a:r>
+              <a:rPr lang="en-US" sz="1200" b="1" dirty="0">
+                <a:solidFill>
+                  <a:srgbClr val="2B2A28"/>
+                </a:solidFill>
+                <a:latin typeface="Calibri" pitchFamily="34" charset="0"/>
+                <a:ea typeface="Calibri" pitchFamily="34" charset="-122"/>
+                <a:cs typeface="Calibri" pitchFamily="34" charset="-120"/>
+              </a:rPr>
+              <a:t>Citation precision</a:t>
+            </a:r>
+            <a:endParaRPr lang="en-US" sz="1200" dirty="0"/>
+          </a:p>
+        </p:txBody>
+      </p:sp>
+      <p:sp>
+        <p:nvSpPr>
+          <p:cNvPr id="5" name="Text 3"/>
+          <p:cNvSpPr txBox="1"/>
+          <p:nvPr/>
+        </p:nvSpPr>
+        <p:spPr>
+          <a:xfrm>
+            <a:off x="457200" y="1645920"/>
+            <a:ext cx="1905610" cy="418011"/>
+          </a:xfrm>
+          <a:prstGeom prst="rect">
+            <a:avLst/>
+          </a:prstGeom>
+          <a:noFill/>
+          <a:ln/>
+        </p:spPr>
+        <p:txBody>
+          <a:bodyPr wrap="square" lIns="0" tIns="0" rIns="0" bIns="0" rtlCol="0" anchor="ctr"/>
+          <a:lstStyle/>
+          <a:p>
+            <a:pPr algn="r" indent="0" marL="0">
+              <a:buNone/>
+            </a:pPr>
+            <a:r>
+              <a:rPr lang="en-US" sz="1050" dirty="0">
+                <a:solidFill>
+                  <a:srgbClr val="2B2A28"/>
+                </a:solidFill>
+                <a:latin typeface="Calibri" pitchFamily="34" charset="0"/>
+                <a:ea typeface="Calibri" pitchFamily="34" charset="-122"/>
+                <a:cs typeface="Calibri" pitchFamily="34" charset="-120"/>
+              </a:rPr>
+              <a:t>Baseline (judge v1)</a:t>
+            </a:r>
+            <a:endParaRPr lang="en-US" sz="1050" dirty="0"/>
+          </a:p>
+        </p:txBody>
+      </p:sp>
+      <p:sp>
+        <p:nvSpPr>
+          <p:cNvPr id="6" name="Shape 4"/>
+          <p:cNvSpPr/>
+          <p:nvPr/>
+        </p:nvSpPr>
+        <p:spPr>
+          <a:xfrm>
+            <a:off x="2454250" y="1725342"/>
+            <a:ext cx="1758830" cy="259167"/>
+          </a:xfrm>
+          <a:prstGeom prst="rect">
+            <a:avLst/>
+          </a:prstGeom>
+          <a:solidFill>
+            <a:srgbClr val="7C9A82"/>
+          </a:solidFill>
+          <a:ln/>
+        </p:spPr>
+      </p:sp>
+      <p:sp>
+        <p:nvSpPr>
+          <p:cNvPr id="7" name="Text 5"/>
+          <p:cNvSpPr txBox="1"/>
+          <p:nvPr/>
+        </p:nvSpPr>
+        <p:spPr>
+          <a:xfrm>
+            <a:off x="4267944" y="1645920"/>
+            <a:ext cx="457200" cy="418011"/>
+          </a:xfrm>
+          <a:prstGeom prst="rect">
+            <a:avLst/>
+          </a:prstGeom>
+          <a:noFill/>
+          <a:ln/>
+        </p:spPr>
+        <p:txBody>
+          <a:bodyPr wrap="square" lIns="0" tIns="0" rIns="0" bIns="0" rtlCol="0" anchor="ctr"/>
+          <a:lstStyle/>
+          <a:p>
+            <a:pPr indent="0" marL="0">
+              <a:buNone/>
+            </a:pPr>
+            <a:r>
+              <a:rPr lang="en-US" sz="1000" b="1" dirty="0">
+                <a:solidFill>
+                  <a:srgbClr val="2B2A28"/>
+                </a:solidFill>
+                <a:latin typeface="Calibri" pitchFamily="34" charset="0"/>
+                <a:ea typeface="Calibri" pitchFamily="34" charset="-122"/>
+                <a:cs typeface="Calibri" pitchFamily="34" charset="-120"/>
+              </a:rPr>
+              <a:t>78%</a:t>
+            </a:r>
+            <a:endParaRPr lang="en-US" sz="1000" dirty="0"/>
+          </a:p>
+        </p:txBody>
+      </p:sp>
+      <p:sp>
+        <p:nvSpPr>
+          <p:cNvPr id="8" name="Text 6"/>
+          <p:cNvSpPr txBox="1"/>
+          <p:nvPr/>
+        </p:nvSpPr>
+        <p:spPr>
+          <a:xfrm>
+            <a:off x="457200" y="2063931"/>
+            <a:ext cx="1905610" cy="418011"/>
+          </a:xfrm>
+          <a:prstGeom prst="rect">
+            <a:avLst/>
+          </a:prstGeom>
+          <a:noFill/>
+          <a:ln/>
+        </p:spPr>
+        <p:txBody>
+          <a:bodyPr wrap="square" lIns="0" tIns="0" rIns="0" bIns="0" rtlCol="0" anchor="ctr"/>
+          <a:lstStyle/>
+          <a:p>
+            <a:pPr algn="r" indent="0" marL="0">
+              <a:buNone/>
+            </a:pPr>
+            <a:r>
+              <a:rPr lang="en-US" sz="1050" dirty="0">
+                <a:solidFill>
+                  <a:srgbClr val="2B2A28"/>
+                </a:solidFill>
+                <a:latin typeface="Calibri" pitchFamily="34" charset="0"/>
+                <a:ea typeface="Calibri" pitchFamily="34" charset="-122"/>
+                <a:cs typeface="Calibri" pitchFamily="34" charset="-120"/>
+              </a:rPr>
+              <a:t>gpt-4.1-mini writer</a:t>
+            </a:r>
+            <a:endParaRPr lang="en-US" sz="1050" dirty="0"/>
+          </a:p>
+        </p:txBody>
+      </p:sp>
+      <p:sp>
+        <p:nvSpPr>
+          <p:cNvPr id="9" name="Shape 7"/>
+          <p:cNvSpPr/>
+          <p:nvPr/>
+        </p:nvSpPr>
+        <p:spPr>
+          <a:xfrm>
+            <a:off x="2454250" y="2143354"/>
+            <a:ext cx="1668634" cy="259167"/>
+          </a:xfrm>
+          <a:prstGeom prst="rect">
+            <a:avLst/>
+          </a:prstGeom>
+          <a:solidFill>
+            <a:srgbClr val="7C9A82"/>
+          </a:solidFill>
+          <a:ln/>
+        </p:spPr>
+      </p:sp>
+      <p:sp>
+        <p:nvSpPr>
+          <p:cNvPr id="10" name="Text 8"/>
+          <p:cNvSpPr txBox="1"/>
+          <p:nvPr/>
+        </p:nvSpPr>
+        <p:spPr>
+          <a:xfrm>
+            <a:off x="4177747" y="2063931"/>
+            <a:ext cx="457200" cy="418011"/>
+          </a:xfrm>
+          <a:prstGeom prst="rect">
+            <a:avLst/>
+          </a:prstGeom>
+          <a:noFill/>
+          <a:ln/>
+        </p:spPr>
+        <p:txBody>
+          <a:bodyPr wrap="square" lIns="0" tIns="0" rIns="0" bIns="0" rtlCol="0" anchor="ctr"/>
+          <a:lstStyle/>
+          <a:p>
+            <a:pPr indent="0" marL="0">
+              <a:buNone/>
+            </a:pPr>
+            <a:r>
+              <a:rPr lang="en-US" sz="1000" b="1" dirty="0">
+                <a:solidFill>
+                  <a:srgbClr val="2B2A28"/>
+                </a:solidFill>
+                <a:latin typeface="Calibri" pitchFamily="34" charset="0"/>
+                <a:ea typeface="Calibri" pitchFamily="34" charset="-122"/>
+                <a:cs typeface="Calibri" pitchFamily="34" charset="-120"/>
+              </a:rPr>
+              <a:t>74%</a:t>
+            </a:r>
+            <a:endParaRPr lang="en-US" sz="1000" dirty="0"/>
+          </a:p>
+        </p:txBody>
+      </p:sp>
+      <p:sp>
+        <p:nvSpPr>
+          <p:cNvPr id="11" name="Text 9"/>
+          <p:cNvSpPr txBox="1"/>
+          <p:nvPr/>
+        </p:nvSpPr>
+        <p:spPr>
+          <a:xfrm>
+            <a:off x="457200" y="2481943"/>
+            <a:ext cx="1905610" cy="418011"/>
+          </a:xfrm>
+          <a:prstGeom prst="rect">
+            <a:avLst/>
+          </a:prstGeom>
+          <a:noFill/>
+          <a:ln/>
+        </p:spPr>
+        <p:txBody>
+          <a:bodyPr wrap="square" lIns="0" tIns="0" rIns="0" bIns="0" rtlCol="0" anchor="ctr"/>
+          <a:lstStyle/>
+          <a:p>
+            <a:pPr algn="r" indent="0" marL="0">
+              <a:buNone/>
+            </a:pPr>
+            <a:r>
+              <a:rPr lang="en-US" sz="1050" dirty="0">
+                <a:solidFill>
+                  <a:srgbClr val="2B2A28"/>
+                </a:solidFill>
+                <a:latin typeface="Calibri" pitchFamily="34" charset="0"/>
+                <a:ea typeface="Calibri" pitchFamily="34" charset="-122"/>
+                <a:cs typeface="Calibri" pitchFamily="34" charset="-120"/>
+              </a:rPr>
+              <a:t>No reranker</a:t>
+            </a:r>
+            <a:endParaRPr lang="en-US" sz="1050" dirty="0"/>
+          </a:p>
+        </p:txBody>
+      </p:sp>
+      <p:sp>
+        <p:nvSpPr>
+          <p:cNvPr id="12" name="Shape 10"/>
+          <p:cNvSpPr/>
+          <p:nvPr/>
+        </p:nvSpPr>
+        <p:spPr>
+          <a:xfrm>
+            <a:off x="2454250" y="2561365"/>
+            <a:ext cx="1578437" cy="259167"/>
+          </a:xfrm>
+          <a:prstGeom prst="rect">
+            <a:avLst/>
+          </a:prstGeom>
+          <a:solidFill>
+            <a:srgbClr val="D86A2E"/>
+          </a:solidFill>
+          <a:ln/>
+        </p:spPr>
+      </p:sp>
+      <p:sp>
+        <p:nvSpPr>
+          <p:cNvPr id="13" name="Text 11"/>
+          <p:cNvSpPr txBox="1"/>
+          <p:nvPr/>
+        </p:nvSpPr>
+        <p:spPr>
+          <a:xfrm>
+            <a:off x="4087551" y="2481943"/>
+            <a:ext cx="457200" cy="418011"/>
+          </a:xfrm>
+          <a:prstGeom prst="rect">
+            <a:avLst/>
+          </a:prstGeom>
+          <a:noFill/>
+          <a:ln/>
+        </p:spPr>
+        <p:txBody>
+          <a:bodyPr wrap="square" lIns="0" tIns="0" rIns="0" bIns="0" rtlCol="0" anchor="ctr"/>
+          <a:lstStyle/>
+          <a:p>
+            <a:pPr indent="0" marL="0">
+              <a:buNone/>
+            </a:pPr>
+            <a:r>
+              <a:rPr lang="en-US" sz="1000" b="1" dirty="0">
+                <a:solidFill>
+                  <a:srgbClr val="2B2A28"/>
+                </a:solidFill>
+                <a:latin typeface="Calibri" pitchFamily="34" charset="0"/>
+                <a:ea typeface="Calibri" pitchFamily="34" charset="-122"/>
+                <a:cs typeface="Calibri" pitchFamily="34" charset="-120"/>
+              </a:rPr>
+              <a:t>70%</a:t>
+            </a:r>
+            <a:endParaRPr lang="en-US" sz="1000" dirty="0"/>
+          </a:p>
+        </p:txBody>
+      </p:sp>
+      <p:sp>
+        <p:nvSpPr>
+          <p:cNvPr id="14" name="Text 12"/>
+          <p:cNvSpPr txBox="1"/>
+          <p:nvPr/>
+        </p:nvSpPr>
+        <p:spPr>
+          <a:xfrm>
+            <a:off x="457200" y="2899954"/>
+            <a:ext cx="1905610" cy="418011"/>
+          </a:xfrm>
+          <a:prstGeom prst="rect">
+            <a:avLst/>
+          </a:prstGeom>
+          <a:noFill/>
+          <a:ln/>
+        </p:spPr>
+        <p:txBody>
+          <a:bodyPr wrap="square" lIns="0" tIns="0" rIns="0" bIns="0" rtlCol="0" anchor="ctr"/>
+          <a:lstStyle/>
+          <a:p>
+            <a:pPr algn="r" indent="0" marL="0">
+              <a:buNone/>
+            </a:pPr>
+            <a:r>
+              <a:rPr lang="en-US" sz="1050" dirty="0">
+                <a:solidFill>
+                  <a:srgbClr val="2B2A28"/>
+                </a:solidFill>
+                <a:latin typeface="Calibri" pitchFamily="34" charset="0"/>
+                <a:ea typeface="Calibri" pitchFamily="34" charset="-122"/>
+                <a:cs typeface="Calibri" pitchFamily="34" charset="-120"/>
+              </a:rPr>
+              <a:t>Single query</a:t>
+            </a:r>
+            <a:endParaRPr lang="en-US" sz="1050" dirty="0"/>
+          </a:p>
+        </p:txBody>
+      </p:sp>
+      <p:sp>
+        <p:nvSpPr>
+          <p:cNvPr id="15" name="Shape 13"/>
+          <p:cNvSpPr/>
+          <p:nvPr/>
+        </p:nvSpPr>
+        <p:spPr>
+          <a:xfrm>
+            <a:off x="2454250" y="2979376"/>
+            <a:ext cx="1803928" cy="259167"/>
+          </a:xfrm>
+          <a:prstGeom prst="rect">
+            <a:avLst/>
+          </a:prstGeom>
+          <a:solidFill>
+            <a:srgbClr val="7C9A82"/>
+          </a:solidFill>
+          <a:ln/>
+        </p:spPr>
+      </p:sp>
+      <p:sp>
+        <p:nvSpPr>
+          <p:cNvPr id="16" name="Text 14"/>
+          <p:cNvSpPr txBox="1"/>
+          <p:nvPr/>
+        </p:nvSpPr>
+        <p:spPr>
+          <a:xfrm>
+            <a:off x="4313042" y="2899954"/>
+            <a:ext cx="457200" cy="418011"/>
+          </a:xfrm>
+          <a:prstGeom prst="rect">
+            <a:avLst/>
+          </a:prstGeom>
+          <a:noFill/>
+          <a:ln/>
+        </p:spPr>
+        <p:txBody>
+          <a:bodyPr wrap="square" lIns="0" tIns="0" rIns="0" bIns="0" rtlCol="0" anchor="ctr"/>
+          <a:lstStyle/>
+          <a:p>
+            <a:pPr indent="0" marL="0">
+              <a:buNone/>
+            </a:pPr>
+            <a:r>
+              <a:rPr lang="en-US" sz="1000" b="1" dirty="0">
+                <a:solidFill>
+                  <a:srgbClr val="2B2A28"/>
+                </a:solidFill>
+                <a:latin typeface="Calibri" pitchFamily="34" charset="0"/>
+                <a:ea typeface="Calibri" pitchFamily="34" charset="-122"/>
+                <a:cs typeface="Calibri" pitchFamily="34" charset="-120"/>
+              </a:rPr>
+              <a:t>80%</a:t>
+            </a:r>
+            <a:endParaRPr lang="en-US" sz="1000" dirty="0"/>
+          </a:p>
+        </p:txBody>
+      </p:sp>
+      <p:sp>
+        <p:nvSpPr>
+          <p:cNvPr id="17" name="Text 15"/>
+          <p:cNvSpPr txBox="1"/>
+          <p:nvPr/>
+        </p:nvSpPr>
+        <p:spPr>
+          <a:xfrm>
+            <a:off x="457200" y="3317966"/>
+            <a:ext cx="1905610" cy="418011"/>
+          </a:xfrm>
+          <a:prstGeom prst="rect">
+            <a:avLst/>
+          </a:prstGeom>
+          <a:noFill/>
+          <a:ln/>
+        </p:spPr>
+        <p:txBody>
+          <a:bodyPr wrap="square" lIns="0" tIns="0" rIns="0" bIns="0" rtlCol="0" anchor="ctr"/>
+          <a:lstStyle/>
+          <a:p>
+            <a:pPr algn="r" indent="0" marL="0">
+              <a:buNone/>
+            </a:pPr>
+            <a:r>
+              <a:rPr lang="en-US" sz="1050" dirty="0">
+                <a:solidFill>
+                  <a:srgbClr val="2B2A28"/>
+                </a:solidFill>
+                <a:latin typeface="Calibri" pitchFamily="34" charset="0"/>
+                <a:ea typeface="Calibri" pitchFamily="34" charset="-122"/>
+                <a:cs typeface="Calibri" pitchFamily="34" charset="-120"/>
+              </a:rPr>
+              <a:t>Prompt v1</a:t>
+            </a:r>
+            <a:endParaRPr lang="en-US" sz="1050" dirty="0"/>
+          </a:p>
+        </p:txBody>
+      </p:sp>
+      <p:sp>
+        <p:nvSpPr>
+          <p:cNvPr id="18" name="Shape 16"/>
+          <p:cNvSpPr/>
+          <p:nvPr/>
+        </p:nvSpPr>
+        <p:spPr>
+          <a:xfrm>
+            <a:off x="2454250" y="3397388"/>
+            <a:ext cx="1646085" cy="259167"/>
+          </a:xfrm>
+          <a:prstGeom prst="rect">
+            <a:avLst/>
+          </a:prstGeom>
+          <a:solidFill>
+            <a:srgbClr val="7C9A82"/>
+          </a:solidFill>
+          <a:ln/>
+        </p:spPr>
+      </p:sp>
+      <p:sp>
+        <p:nvSpPr>
+          <p:cNvPr id="19" name="Text 17"/>
+          <p:cNvSpPr txBox="1"/>
+          <p:nvPr/>
+        </p:nvSpPr>
+        <p:spPr>
+          <a:xfrm>
+            <a:off x="4155198" y="3317966"/>
+            <a:ext cx="457200" cy="418011"/>
+          </a:xfrm>
+          <a:prstGeom prst="rect">
+            <a:avLst/>
+          </a:prstGeom>
+          <a:noFill/>
+          <a:ln/>
+        </p:spPr>
+        <p:txBody>
+          <a:bodyPr wrap="square" lIns="0" tIns="0" rIns="0" bIns="0" rtlCol="0" anchor="ctr"/>
+          <a:lstStyle/>
+          <a:p>
+            <a:pPr indent="0" marL="0">
+              <a:buNone/>
+            </a:pPr>
+            <a:r>
+              <a:rPr lang="en-US" sz="1000" b="1" dirty="0">
+                <a:solidFill>
+                  <a:srgbClr val="2B2A28"/>
+                </a:solidFill>
+                <a:latin typeface="Calibri" pitchFamily="34" charset="0"/>
+                <a:ea typeface="Calibri" pitchFamily="34" charset="-122"/>
+                <a:cs typeface="Calibri" pitchFamily="34" charset="-120"/>
+              </a:rPr>
+              <a:t>73%</a:t>
+            </a:r>
+            <a:endParaRPr lang="en-US" sz="1000" dirty="0"/>
+          </a:p>
+        </p:txBody>
+      </p:sp>
+      <p:sp>
+        <p:nvSpPr>
+          <p:cNvPr id="20" name="Text 18"/>
+          <p:cNvSpPr txBox="1"/>
+          <p:nvPr/>
+        </p:nvSpPr>
+        <p:spPr>
+          <a:xfrm>
+            <a:off x="457200" y="3735977"/>
+            <a:ext cx="1905610" cy="418011"/>
+          </a:xfrm>
+          <a:prstGeom prst="rect">
+            <a:avLst/>
+          </a:prstGeom>
+          <a:noFill/>
+          <a:ln/>
+        </p:spPr>
+        <p:txBody>
+          <a:bodyPr wrap="square" lIns="0" tIns="0" rIns="0" bIns="0" rtlCol="0" anchor="ctr"/>
+          <a:lstStyle/>
+          <a:p>
+            <a:pPr algn="r" indent="0" marL="0">
+              <a:buNone/>
+            </a:pPr>
+            <a:r>
+              <a:rPr lang="en-US" sz="1050" dirty="0">
+                <a:solidFill>
+                  <a:srgbClr val="2B2A28"/>
+                </a:solidFill>
+                <a:latin typeface="Calibri" pitchFamily="34" charset="0"/>
+                <a:ea typeface="Calibri" pitchFamily="34" charset="-122"/>
+                <a:cs typeface="Calibri" pitchFamily="34" charset="-120"/>
+              </a:rPr>
+              <a:t>No citation loop</a:t>
+            </a:r>
+            <a:endParaRPr lang="en-US" sz="1050" dirty="0"/>
+          </a:p>
+        </p:txBody>
+      </p:sp>
+      <p:sp>
+        <p:nvSpPr>
+          <p:cNvPr id="21" name="Shape 19"/>
+          <p:cNvSpPr/>
+          <p:nvPr/>
+        </p:nvSpPr>
+        <p:spPr>
+          <a:xfrm>
+            <a:off x="2454250" y="3815399"/>
+            <a:ext cx="1646085" cy="259167"/>
+          </a:xfrm>
+          <a:prstGeom prst="rect">
+            <a:avLst/>
+          </a:prstGeom>
+          <a:solidFill>
+            <a:srgbClr val="7C9A82"/>
+          </a:solidFill>
+          <a:ln/>
+        </p:spPr>
+      </p:sp>
+      <p:sp>
+        <p:nvSpPr>
+          <p:cNvPr id="22" name="Text 20"/>
+          <p:cNvSpPr txBox="1"/>
+          <p:nvPr/>
+        </p:nvSpPr>
+        <p:spPr>
+          <a:xfrm>
+            <a:off x="4155198" y="3735977"/>
+            <a:ext cx="457200" cy="418011"/>
+          </a:xfrm>
+          <a:prstGeom prst="rect">
+            <a:avLst/>
+          </a:prstGeom>
+          <a:noFill/>
+          <a:ln/>
+        </p:spPr>
+        <p:txBody>
+          <a:bodyPr wrap="square" lIns="0" tIns="0" rIns="0" bIns="0" rtlCol="0" anchor="ctr"/>
+          <a:lstStyle/>
+          <a:p>
+            <a:pPr indent="0" marL="0">
+              <a:buNone/>
+            </a:pPr>
+            <a:r>
+              <a:rPr lang="en-US" sz="1000" b="1" dirty="0">
+                <a:solidFill>
+                  <a:srgbClr val="2B2A28"/>
+                </a:solidFill>
+                <a:latin typeface="Calibri" pitchFamily="34" charset="0"/>
+                <a:ea typeface="Calibri" pitchFamily="34" charset="-122"/>
+                <a:cs typeface="Calibri" pitchFamily="34" charset="-120"/>
+              </a:rPr>
+              <a:t>73%</a:t>
+            </a:r>
+            <a:endParaRPr lang="en-US" sz="1000" dirty="0"/>
+          </a:p>
+        </p:txBody>
+      </p:sp>
+      <p:sp>
+        <p:nvSpPr>
+          <p:cNvPr id="23" name="Text 21"/>
+          <p:cNvSpPr txBox="1"/>
+          <p:nvPr/>
+        </p:nvSpPr>
+        <p:spPr>
+          <a:xfrm>
+            <a:off x="457200" y="4153989"/>
+            <a:ext cx="1905610" cy="418011"/>
+          </a:xfrm>
+          <a:prstGeom prst="rect">
+            <a:avLst/>
+          </a:prstGeom>
+          <a:noFill/>
+          <a:ln/>
+        </p:spPr>
+        <p:txBody>
+          <a:bodyPr wrap="square" lIns="0" tIns="0" rIns="0" bIns="0" rtlCol="0" anchor="ctr"/>
+          <a:lstStyle/>
+          <a:p>
+            <a:pPr algn="r" indent="0" marL="0">
+              <a:buNone/>
+            </a:pPr>
+            <a:r>
+              <a:rPr lang="en-US" sz="1050" dirty="0">
+                <a:solidFill>
+                  <a:srgbClr val="2B2A28"/>
+                </a:solidFill>
+                <a:latin typeface="Calibri" pitchFamily="34" charset="0"/>
+                <a:ea typeface="Calibri" pitchFamily="34" charset="-122"/>
+                <a:cs typeface="Calibri" pitchFamily="34" charset="-120"/>
+              </a:rPr>
+              <a:t>Final (judge v2, mean of 3)</a:t>
+            </a:r>
+            <a:endParaRPr lang="en-US" sz="1050" dirty="0"/>
+          </a:p>
+        </p:txBody>
+      </p:sp>
+      <p:sp>
+        <p:nvSpPr>
+          <p:cNvPr id="24" name="Shape 22"/>
+          <p:cNvSpPr/>
+          <p:nvPr/>
+        </p:nvSpPr>
+        <p:spPr>
+          <a:xfrm>
+            <a:off x="2454250" y="4233411"/>
+            <a:ext cx="2119616" cy="259167"/>
+          </a:xfrm>
+          <a:prstGeom prst="rect">
+            <a:avLst/>
+          </a:prstGeom>
+          <a:solidFill>
+            <a:srgbClr val="138A72"/>
+          </a:solidFill>
+          <a:ln/>
+        </p:spPr>
+      </p:sp>
+      <p:sp>
+        <p:nvSpPr>
+          <p:cNvPr id="25" name="Text 23"/>
+          <p:cNvSpPr txBox="1"/>
+          <p:nvPr/>
+        </p:nvSpPr>
+        <p:spPr>
+          <a:xfrm>
+            <a:off x="4628729" y="4153989"/>
+            <a:ext cx="457200" cy="418011"/>
+          </a:xfrm>
+          <a:prstGeom prst="rect">
+            <a:avLst/>
+          </a:prstGeom>
+          <a:noFill/>
+          <a:ln/>
+        </p:spPr>
+        <p:txBody>
+          <a:bodyPr wrap="square" lIns="0" tIns="0" rIns="0" bIns="0" rtlCol="0" anchor="ctr"/>
+          <a:lstStyle/>
+          <a:p>
+            <a:pPr indent="0" marL="0">
+              <a:buNone/>
+            </a:pPr>
+            <a:r>
+              <a:rPr lang="en-US" sz="1000" b="1" dirty="0">
+                <a:solidFill>
+                  <a:srgbClr val="2B2A28"/>
+                </a:solidFill>
+                <a:latin typeface="Calibri" pitchFamily="34" charset="0"/>
+                <a:ea typeface="Calibri" pitchFamily="34" charset="-122"/>
+                <a:cs typeface="Calibri" pitchFamily="34" charset="-120"/>
+              </a:rPr>
+              <a:t>94%</a:t>
+            </a:r>
+            <a:endParaRPr lang="en-US" sz="1000" dirty="0"/>
+          </a:p>
+        </p:txBody>
+      </p:sp>
+      <p:sp>
+        <p:nvSpPr>
+          <p:cNvPr id="26" name="Text 24"/>
           <p:cNvSpPr txBox="1"/>
           <p:nvPr/>
         </p:nvSpPr>
@@ -4796,7 +5781,7 @@
       </p:sp>
       <p:sp>
         <p:nvSpPr>
-          <p:cNvPr id="6" name="Text 3"/>
+          <p:cNvPr id="27" name="Text 25"/>
           <p:cNvSpPr txBox="1"/>
           <p:nvPr/>
         </p:nvSpPr>
@@ -4852,7 +5837,7 @@
       </p:sp>
       <p:sp>
         <p:nvSpPr>
-          <p:cNvPr id="7" name="Text 4"/>
+          <p:cNvPr id="28" name="Text 26"/>
           <p:cNvSpPr txBox="1"/>
           <p:nvPr/>
         </p:nvSpPr>
@@ -4891,7 +5876,7 @@
       </p:sp>
       <p:sp>
         <p:nvSpPr>
-          <p:cNvPr id="8" name="Text 5"/>
+          <p:cNvPr id="29" name="Text 27"/>
           <p:cNvSpPr txBox="1"/>
           <p:nvPr/>
         </p:nvSpPr>
@@ -4947,7 +5932,7 @@
       </p:sp>
       <p:sp>
         <p:nvSpPr>
-          <p:cNvPr id="9" name="Text 6"/>
+          <p:cNvPr id="30" name="Text 28"/>
           <p:cNvSpPr txBox="1"/>
           <p:nvPr/>
         </p:nvSpPr>
@@ -4986,7 +5971,7 @@
       </p:sp>
       <p:sp>
         <p:nvSpPr>
-          <p:cNvPr id="10" name="Text 7"/>
+          <p:cNvPr id="31" name="Text 29"/>
           <p:cNvSpPr txBox="1"/>
           <p:nvPr/>
         </p:nvSpPr>
@@ -5105,7 +6090,7 @@
                 <a:ea typeface="Cambria" pitchFamily="34" charset="-122"/>
                 <a:cs typeface="Cambria" pitchFamily="34" charset="-120"/>
               </a:rPr>
-              <a:t>What broke on real data, and what I learned</a:t>
+              <a:t>Every request traced in LangSmith</a:t>
             </a:r>
             <a:endParaRPr lang="en-US" sz="3000" dirty="0"/>
           </a:p>
@@ -5144,31 +6129,50 @@
                 <a:ea typeface="Calibri" pitchFamily="34" charset="-122"/>
                 <a:cs typeface="Calibri" pitchFamily="34" charset="-120"/>
               </a:rPr>
-              <a:t>Demo data passed every test; my own exports didn't</a:t>
+              <a:t>One trace per chat turn: graph nodes, LLM calls, retriever and MCP tools, tagged by persona and eval run</a:t>
             </a:r>
             <a:endParaRPr lang="en-US" sz="1400" dirty="0"/>
           </a:p>
         </p:txBody>
       </p:sp>
-      <p:sp>
-        <p:nvSpPr>
-          <p:cNvPr id="4" name="Shape 2"/>
+      <p:pic>
+        <p:nvPicPr>
+          <p:cNvPr id="4" name="Image 0" descr="/Users/damilya/Projects/n17_LLM/Projects/final-project/docs/deck/img/langsmith.jpg">    </p:cNvPr>
+          <p:cNvPicPr>
+            <a:picLocks noChangeAspect="1"/>
+          </p:cNvPicPr>
+          <p:nvPr/>
+        </p:nvPicPr>
+        <p:blipFill>
+          <a:blip r:embed="rId1"/>
+          <a:stretch>
+            <a:fillRect/>
+          </a:stretch>
+        </p:blipFill>
+        <p:spPr>
+          <a:xfrm>
+            <a:off x="457200" y="1280160"/>
+            <a:ext cx="4709160" cy="3200400"/>
+          </a:xfrm>
+          <a:prstGeom prst="rect">
+            <a:avLst/>
+          </a:prstGeom>
+        </p:spPr>
+      </p:pic>
+      <p:sp>
+        <p:nvSpPr>
+          <p:cNvPr id="5" name="Shape 2"/>
           <p:cNvSpPr/>
           <p:nvPr/>
         </p:nvSpPr>
         <p:spPr>
           <a:xfrm>
             <a:off x="457200" y="1280160"/>
-            <a:ext cx="4069080" cy="1005840"/>
-          </a:xfrm>
-          <a:prstGeom prst="roundRect">
-            <a:avLst>
-              <a:gd name="adj" fmla="val 10909"/>
-            </a:avLst>
-          </a:prstGeom>
-          <a:solidFill>
-            <a:srgbClr val="FFFFFF"/>
-          </a:solidFill>
+            <a:ext cx="4709160" cy="3200400"/>
+          </a:xfrm>
+          <a:prstGeom prst="rect">
+            <a:avLst/>
+          </a:prstGeom>
           <a:ln w="9525">
             <a:solidFill>
               <a:srgbClr val="E6E1D8"/>
@@ -5179,13 +6183,52 @@
       </p:sp>
       <p:sp>
         <p:nvSpPr>
-          <p:cNvPr id="5" name="Shape 3"/>
+          <p:cNvPr id="6" name="Text 3"/>
+          <p:cNvSpPr txBox="1"/>
+          <p:nvPr/>
+        </p:nvSpPr>
+        <p:spPr>
+          <a:xfrm>
+            <a:off x="457200" y="4526280"/>
+            <a:ext cx="4709160" cy="228600"/>
+          </a:xfrm>
+          <a:prstGeom prst="rect">
+            <a:avLst/>
+          </a:prstGeom>
+          <a:noFill/>
+          <a:ln/>
+        </p:spPr>
+        <p:txBody>
+          <a:bodyPr wrap="square" lIns="0" tIns="0" rIns="0" bIns="0" rtlCol="0" anchor="ctr"/>
+          <a:lstStyle/>
+          <a:p>
+            <a:pPr indent="0" marL="0">
+              <a:buNone/>
+            </a:pPr>
+            <a:r>
+              <a:rPr lang="en-US" sz="900" i="1" dirty="0">
+                <a:solidFill>
+                  <a:srgbClr val="6F6A62"/>
+                </a:solidFill>
+                <a:latin typeface="Calibri" pitchFamily="34" charset="0"/>
+                <a:ea typeface="Calibri" pitchFamily="34" charset="-122"/>
+                <a:cs typeface="Calibri" pitchFamily="34" charset="-120"/>
+              </a:rPr>
+              <a:t>Screenshot: LangSmith tracing project (1,293 traces in a day of evals and demos)</a:t>
+            </a:r>
+            <a:endParaRPr lang="en-US" sz="900" dirty="0"/>
+          </a:p>
+        </p:txBody>
+      </p:sp>
+      <p:sp>
+        <p:nvSpPr>
+          <p:cNvPr id="7" name="Shape 4"/>
           <p:cNvSpPr/>
           <p:nvPr/>
         </p:nvSpPr>
         <p:spPr>
           <a:xfrm>
-            <a:off x="594360" y="1435608"/>
+            <a:off x="5440680" y="1325880"/>
             <a:ext cx="237744" cy="237744"/>
           </a:xfrm>
           <a:prstGeom prst="ellipse">
@@ -5199,14 +6242,14 @@
       </p:sp>
       <p:sp>
         <p:nvSpPr>
-          <p:cNvPr id="6" name="Text 4"/>
+          <p:cNvPr id="8" name="Text 5"/>
           <p:cNvSpPr txBox="1"/>
           <p:nvPr/>
         </p:nvSpPr>
         <p:spPr>
           <a:xfrm>
-            <a:off x="960120" y="1371600"/>
-            <a:ext cx="3429000" cy="841248"/>
+            <a:off x="5806440" y="1280160"/>
+            <a:ext cx="2880360" cy="1005840"/>
           </a:xfrm>
           <a:prstGeom prst="rect">
             <a:avLst/>
@@ -5230,7 +6273,7 @@
                 <a:ea typeface="Calibri" pitchFamily="34" charset="-122"/>
                 <a:cs typeface="Calibri" pitchFamily="34" charset="-120"/>
               </a:rPr>
-              <a:t>Timezones</a:t>
+              <a:t>Debug</a:t>
             </a:r>
             <a:endParaRPr lang="en-US" sz="1250" dirty="0"/>
           </a:p>
@@ -5239,15 +6282,15 @@
               <a:buNone/>
             </a:pPr>
             <a:r>
-              <a:rPr lang="en-US" sz="1000" dirty="0">
-                <a:solidFill>
-                  <a:srgbClr val="2B2A28"/>
-                </a:solidFill>
-                <a:latin typeface="Calibri" pitchFamily="34" charset="0"/>
-                <a:ea typeface="Calibri" pitchFamily="34" charset="-122"/>
-                <a:cs typeface="Calibri" pitchFamily="34" charset="-120"/>
-              </a:rPr>
-              <a:t>Apple Health stamped everything +05:00 (the phone's zone at export) → workouts 4 h off, dedupe failed. Now one HOME_TZ for all sources.</a:t>
+              <a:rPr lang="en-US" sz="1050" dirty="0">
+                <a:solidFill>
+                  <a:srgbClr val="2B2A28"/>
+                </a:solidFill>
+                <a:latin typeface="Calibri" pitchFamily="34" charset="0"/>
+                <a:ea typeface="Calibri" pitchFamily="34" charset="-122"/>
+                <a:cs typeface="Calibri" pitchFamily="34" charset="-120"/>
+              </a:rPr>
+              <a:t>Open a trace to see triage → retrieve → generate → citation_check, with each rewrite of the loop as its own span.</a:t>
             </a:r>
             <a:endParaRPr lang="en-US" sz="1250" dirty="0"/>
           </a:p>
@@ -5255,40 +6298,13 @@
       </p:sp>
       <p:sp>
         <p:nvSpPr>
-          <p:cNvPr id="7" name="Shape 5"/>
+          <p:cNvPr id="9" name="Shape 6"/>
           <p:cNvSpPr/>
           <p:nvPr/>
         </p:nvSpPr>
         <p:spPr>
           <a:xfrm>
-            <a:off x="4617720" y="1280160"/>
-            <a:ext cx="4069080" cy="1005840"/>
-          </a:xfrm>
-          <a:prstGeom prst="roundRect">
-            <a:avLst>
-              <a:gd name="adj" fmla="val 10909"/>
-            </a:avLst>
-          </a:prstGeom>
-          <a:solidFill>
-            <a:srgbClr val="FFFFFF"/>
-          </a:solidFill>
-          <a:ln w="9525">
-            <a:solidFill>
-              <a:srgbClr val="E6E1D8"/>
-            </a:solidFill>
-            <a:prstDash val="solid"/>
-          </a:ln>
-        </p:spPr>
-      </p:sp>
-      <p:sp>
-        <p:nvSpPr>
-          <p:cNvPr id="8" name="Shape 6"/>
-          <p:cNvSpPr/>
-          <p:nvPr/>
-        </p:nvSpPr>
-        <p:spPr>
-          <a:xfrm>
-            <a:off x="4754880" y="1435608"/>
+            <a:off x="5440680" y="2423160"/>
             <a:ext cx="237744" cy="237744"/>
           </a:xfrm>
           <a:prstGeom prst="ellipse">
@@ -5302,14 +6318,14 @@
       </p:sp>
       <p:sp>
         <p:nvSpPr>
-          <p:cNvPr id="9" name="Text 7"/>
+          <p:cNvPr id="10" name="Text 7"/>
           <p:cNvSpPr txBox="1"/>
           <p:nvPr/>
         </p:nvSpPr>
         <p:spPr>
           <a:xfrm>
-            <a:off x="5120640" y="1371600"/>
-            <a:ext cx="3429000" cy="841248"/>
+            <a:off x="5806440" y="2377440"/>
+            <a:ext cx="2880360" cy="1005840"/>
           </a:xfrm>
           <a:prstGeom prst="rect">
             <a:avLst/>
@@ -5333,7 +6349,7 @@
                 <a:ea typeface="Calibri" pitchFamily="34" charset="-122"/>
                 <a:cs typeface="Calibri" pitchFamily="34" charset="-120"/>
               </a:rPr>
-              <a:t>Same event, 3 apps</a:t>
+              <a:t>Cost &amp; latency</a:t>
             </a:r>
             <a:endParaRPr lang="en-US" sz="1250" dirty="0"/>
           </a:p>
@@ -5342,15 +6358,15 @@
               <a:buNone/>
             </a:pPr>
             <a:r>
-              <a:rPr lang="en-US" sz="1000" dirty="0">
-                <a:solidFill>
-                  <a:srgbClr val="2B2A28"/>
-                </a:solidFill>
-                <a:latin typeface="Calibri" pitchFamily="34" charset="0"/>
-                <a:ea typeface="Calibri" pitchFamily="34" charset="-122"/>
-                <a:cs typeface="Calibri" pitchFamily="34" charset="-120"/>
-              </a:rPr>
-              <a:t>Mywellness mirrors the Watch (66 walks) and Withings (220 readings); the Watch re-records gym visits (55). Cross-source dedupe after every import.</a:t>
+              <a:rPr lang="en-US" sz="1050" dirty="0">
+                <a:solidFill>
+                  <a:srgbClr val="2B2A28"/>
+                </a:solidFill>
+                <a:latin typeface="Calibri" pitchFamily="34" charset="0"/>
+                <a:ea typeface="Calibri" pitchFamily="34" charset="-122"/>
+                <a:cs typeface="Calibri" pitchFamily="34" charset="-120"/>
+              </a:rPr>
+              <a:t>Tokens and $ per LLM call; that's where the ≈ $0.009 per research answer comes from.</a:t>
             </a:r>
             <a:endParaRPr lang="en-US" sz="1250" dirty="0"/>
           </a:p>
@@ -5358,40 +6374,13 @@
       </p:sp>
       <p:sp>
         <p:nvSpPr>
-          <p:cNvPr id="10" name="Shape 8"/>
+          <p:cNvPr id="11" name="Shape 8"/>
           <p:cNvSpPr/>
           <p:nvPr/>
         </p:nvSpPr>
         <p:spPr>
           <a:xfrm>
-            <a:off x="457200" y="2395728"/>
-            <a:ext cx="4069080" cy="1005840"/>
-          </a:xfrm>
-          <a:prstGeom prst="roundRect">
-            <a:avLst>
-              <a:gd name="adj" fmla="val 10909"/>
-            </a:avLst>
-          </a:prstGeom>
-          <a:solidFill>
-            <a:srgbClr val="FFFFFF"/>
-          </a:solidFill>
-          <a:ln w="9525">
-            <a:solidFill>
-              <a:srgbClr val="E6E1D8"/>
-            </a:solidFill>
-            <a:prstDash val="solid"/>
-          </a:ln>
-        </p:spPr>
-      </p:sp>
-      <p:sp>
-        <p:nvSpPr>
-          <p:cNvPr id="11" name="Shape 9"/>
-          <p:cNvSpPr/>
-          <p:nvPr/>
-        </p:nvSpPr>
-        <p:spPr>
-          <a:xfrm>
-            <a:off x="594360" y="2551176"/>
+            <a:off x="5440680" y="3520440"/>
             <a:ext cx="237744" cy="237744"/>
           </a:xfrm>
           <a:prstGeom prst="ellipse">
@@ -5405,14 +6394,14 @@
       </p:sp>
       <p:sp>
         <p:nvSpPr>
-          <p:cNvPr id="12" name="Text 10"/>
+          <p:cNvPr id="12" name="Text 9"/>
           <p:cNvSpPr txBox="1"/>
           <p:nvPr/>
         </p:nvSpPr>
         <p:spPr>
           <a:xfrm>
-            <a:off x="960120" y="2487168"/>
-            <a:ext cx="3429000" cy="841248"/>
+            <a:off x="5806440" y="3474720"/>
+            <a:ext cx="2880360" cy="1005840"/>
           </a:xfrm>
           <a:prstGeom prst="rect">
             <a:avLst/>
@@ -5436,7 +6425,7 @@
                 <a:ea typeface="Calibri" pitchFamily="34" charset="-122"/>
                 <a:cs typeface="Calibri" pitchFamily="34" charset="-120"/>
               </a:rPr>
-              <a:t>Format drift</a:t>
+              <a:t>Experiments</a:t>
             </a:r>
             <a:endParaRPr lang="en-US" sz="1250" dirty="0"/>
           </a:p>
@@ -5445,324 +6434,15 @@
               <a:buNone/>
             </a:pPr>
             <a:r>
-              <a:rPr lang="en-US" sz="1000" dirty="0">
-                <a:solidFill>
-                  <a:srgbClr val="2B2A28"/>
-                </a:solidFill>
-                <a:latin typeface="Calibri" pitchFamily="34" charset="0"/>
-                <a:ea typeface="Calibri" pitchFamily="34" charset="-122"/>
-                <a:cs typeface="Calibri" pitchFamily="34" charset="-120"/>
-              </a:rPr>
-              <a:t>Newer iOS writes VaginalBleeding* instead of MenstrualFlow*: 0 of 202 cycle records imported until fixed.</a:t>
-            </a:r>
-            <a:endParaRPr lang="en-US" sz="1250" dirty="0"/>
-          </a:p>
-        </p:txBody>
-      </p:sp>
-      <p:sp>
-        <p:nvSpPr>
-          <p:cNvPr id="13" name="Shape 11"/>
-          <p:cNvSpPr/>
-          <p:nvPr/>
-        </p:nvSpPr>
-        <p:spPr>
-          <a:xfrm>
-            <a:off x="4617720" y="2395728"/>
-            <a:ext cx="4069080" cy="1005840"/>
-          </a:xfrm>
-          <a:prstGeom prst="roundRect">
-            <a:avLst>
-              <a:gd name="adj" fmla="val 10909"/>
-            </a:avLst>
-          </a:prstGeom>
-          <a:solidFill>
-            <a:srgbClr val="FFFFFF"/>
-          </a:solidFill>
-          <a:ln w="9525">
-            <a:solidFill>
-              <a:srgbClr val="E6E1D8"/>
-            </a:solidFill>
-            <a:prstDash val="solid"/>
-          </a:ln>
-        </p:spPr>
-      </p:sp>
-      <p:sp>
-        <p:nvSpPr>
-          <p:cNvPr id="14" name="Shape 12"/>
-          <p:cNvSpPr/>
-          <p:nvPr/>
-        </p:nvSpPr>
-        <p:spPr>
-          <a:xfrm>
-            <a:off x="4754880" y="2551176"/>
-            <a:ext cx="237744" cy="237744"/>
-          </a:xfrm>
-          <a:prstGeom prst="ellipse">
-            <a:avLst/>
-          </a:prstGeom>
-          <a:solidFill>
-            <a:srgbClr val="C47A5A"/>
-          </a:solidFill>
-          <a:ln/>
-        </p:spPr>
-      </p:sp>
-      <p:sp>
-        <p:nvSpPr>
-          <p:cNvPr id="15" name="Text 13"/>
-          <p:cNvSpPr txBox="1"/>
-          <p:nvPr/>
-        </p:nvSpPr>
-        <p:spPr>
-          <a:xfrm>
-            <a:off x="5120640" y="2487168"/>
-            <a:ext cx="3429000" cy="841248"/>
-          </a:xfrm>
-          <a:prstGeom prst="rect">
-            <a:avLst/>
-          </a:prstGeom>
-          <a:noFill/>
-          <a:ln/>
-        </p:spPr>
-        <p:txBody>
-          <a:bodyPr wrap="square" lIns="0" tIns="0" rIns="0" bIns="0" rtlCol="0" anchor="t"/>
-          <a:lstStyle/>
-          <a:p>
-            <a:pPr indent="0" marL="0">
-              <a:buNone/>
-            </a:pPr>
-            <a:r>
-              <a:rPr lang="en-US" sz="1250" b="1" dirty="0">
-                <a:solidFill>
-                  <a:srgbClr val="2B2A28"/>
-                </a:solidFill>
-                <a:latin typeface="Calibri" pitchFamily="34" charset="0"/>
-                <a:ea typeface="Calibri" pitchFamily="34" charset="-122"/>
-                <a:cs typeface="Calibri" pitchFamily="34" charset="-120"/>
-              </a:rPr>
-              <a:t>Lenient self-check</a:t>
-            </a:r>
-            <a:endParaRPr lang="en-US" sz="1250" dirty="0"/>
-          </a:p>
-          <a:p>
-            <a:pPr indent="0" marL="0">
-              <a:buNone/>
-            </a:pPr>
-            <a:r>
-              <a:rPr lang="en-US" sz="1000" dirty="0">
-                <a:solidFill>
-                  <a:srgbClr val="2B2A28"/>
-                </a:solidFill>
-                <a:latin typeface="Calibri" pitchFamily="34" charset="0"/>
-                <a:ea typeface="Calibri" pitchFamily="34" charset="-122"/>
-                <a:cs typeface="Calibri" pitchFamily="34" charset="-120"/>
-              </a:rPr>
-              <a:t>The in-graph citation judge passed 95 % of answers; the offline eval found 22 % unsupported citations → per-claim judge.</a:t>
-            </a:r>
-            <a:endParaRPr lang="en-US" sz="1250" dirty="0"/>
-          </a:p>
-        </p:txBody>
-      </p:sp>
-      <p:sp>
-        <p:nvSpPr>
-          <p:cNvPr id="16" name="Shape 14"/>
-          <p:cNvSpPr/>
-          <p:nvPr/>
-        </p:nvSpPr>
-        <p:spPr>
-          <a:xfrm>
-            <a:off x="457200" y="3511296"/>
-            <a:ext cx="4069080" cy="1005840"/>
-          </a:xfrm>
-          <a:prstGeom prst="roundRect">
-            <a:avLst>
-              <a:gd name="adj" fmla="val 10909"/>
-            </a:avLst>
-          </a:prstGeom>
-          <a:solidFill>
-            <a:srgbClr val="FFFFFF"/>
-          </a:solidFill>
-          <a:ln w="9525">
-            <a:solidFill>
-              <a:srgbClr val="E6E1D8"/>
-            </a:solidFill>
-            <a:prstDash val="solid"/>
-          </a:ln>
-        </p:spPr>
-      </p:sp>
-      <p:sp>
-        <p:nvSpPr>
-          <p:cNvPr id="17" name="Shape 15"/>
-          <p:cNvSpPr/>
-          <p:nvPr/>
-        </p:nvSpPr>
-        <p:spPr>
-          <a:xfrm>
-            <a:off x="594360" y="3666744"/>
-            <a:ext cx="237744" cy="237744"/>
-          </a:xfrm>
-          <a:prstGeom prst="ellipse">
-            <a:avLst/>
-          </a:prstGeom>
-          <a:solidFill>
-            <a:srgbClr val="7C9A82"/>
-          </a:solidFill>
-          <a:ln/>
-        </p:spPr>
-      </p:sp>
-      <p:sp>
-        <p:nvSpPr>
-          <p:cNvPr id="18" name="Text 16"/>
-          <p:cNvSpPr txBox="1"/>
-          <p:nvPr/>
-        </p:nvSpPr>
-        <p:spPr>
-          <a:xfrm>
-            <a:off x="960120" y="3602736"/>
-            <a:ext cx="3429000" cy="841248"/>
-          </a:xfrm>
-          <a:prstGeom prst="rect">
-            <a:avLst/>
-          </a:prstGeom>
-          <a:noFill/>
-          <a:ln/>
-        </p:spPr>
-        <p:txBody>
-          <a:bodyPr wrap="square" lIns="0" tIns="0" rIns="0" bIns="0" rtlCol="0" anchor="t"/>
-          <a:lstStyle/>
-          <a:p>
-            <a:pPr indent="0" marL="0">
-              <a:buNone/>
-            </a:pPr>
-            <a:r>
-              <a:rPr lang="en-US" sz="1250" b="1" dirty="0">
-                <a:solidFill>
-                  <a:srgbClr val="2B2A28"/>
-                </a:solidFill>
-                <a:latin typeface="Calibri" pitchFamily="34" charset="0"/>
-                <a:ea typeface="Calibri" pitchFamily="34" charset="-122"/>
-                <a:cs typeface="Calibri" pitchFamily="34" charset="-120"/>
-              </a:rPr>
-              <a:t>Over-eager goals</a:t>
-            </a:r>
-            <a:endParaRPr lang="en-US" sz="1250" dirty="0"/>
-          </a:p>
-          <a:p>
-            <a:pPr indent="0" marL="0">
-              <a:buNone/>
-            </a:pPr>
-            <a:r>
-              <a:rPr lang="en-US" sz="1000" dirty="0">
-                <a:solidFill>
-                  <a:srgbClr val="2B2A28"/>
-                </a:solidFill>
-                <a:latin typeface="Calibri" pitchFamily="34" charset="0"/>
-                <a:ea typeface="Calibri" pitchFamily="34" charset="-122"/>
-                <a:cs typeface="Calibri" pitchFamily="34" charset="-120"/>
-              </a:rPr>
-              <a:t>“How should I adjust training this week?” triggered goal approval → stricter triage + a negative golden example.</a:t>
-            </a:r>
-            <a:endParaRPr lang="en-US" sz="1250" dirty="0"/>
-          </a:p>
-        </p:txBody>
-      </p:sp>
-      <p:sp>
-        <p:nvSpPr>
-          <p:cNvPr id="19" name="Shape 17"/>
-          <p:cNvSpPr/>
-          <p:nvPr/>
-        </p:nvSpPr>
-        <p:spPr>
-          <a:xfrm>
-            <a:off x="4617720" y="3511296"/>
-            <a:ext cx="4069080" cy="1005840"/>
-          </a:xfrm>
-          <a:prstGeom prst="roundRect">
-            <a:avLst>
-              <a:gd name="adj" fmla="val 10909"/>
-            </a:avLst>
-          </a:prstGeom>
-          <a:solidFill>
-            <a:srgbClr val="FFFFFF"/>
-          </a:solidFill>
-          <a:ln w="9525">
-            <a:solidFill>
-              <a:srgbClr val="E6E1D8"/>
-            </a:solidFill>
-            <a:prstDash val="solid"/>
-          </a:ln>
-        </p:spPr>
-      </p:sp>
-      <p:sp>
-        <p:nvSpPr>
-          <p:cNvPr id="20" name="Shape 18"/>
-          <p:cNvSpPr/>
-          <p:nvPr/>
-        </p:nvSpPr>
-        <p:spPr>
-          <a:xfrm>
-            <a:off x="4754880" y="3666744"/>
-            <a:ext cx="237744" cy="237744"/>
-          </a:xfrm>
-          <a:prstGeom prst="ellipse">
-            <a:avLst/>
-          </a:prstGeom>
-          <a:solidFill>
-            <a:srgbClr val="D8A7A0"/>
-          </a:solidFill>
-          <a:ln/>
-        </p:spPr>
-      </p:sp>
-      <p:sp>
-        <p:nvSpPr>
-          <p:cNvPr id="21" name="Text 19"/>
-          <p:cNvSpPr txBox="1"/>
-          <p:nvPr/>
-        </p:nvSpPr>
-        <p:spPr>
-          <a:xfrm>
-            <a:off x="5120640" y="3602736"/>
-            <a:ext cx="3429000" cy="841248"/>
-          </a:xfrm>
-          <a:prstGeom prst="rect">
-            <a:avLst/>
-          </a:prstGeom>
-          <a:noFill/>
-          <a:ln/>
-        </p:spPr>
-        <p:txBody>
-          <a:bodyPr wrap="square" lIns="0" tIns="0" rIns="0" bIns="0" rtlCol="0" anchor="t"/>
-          <a:lstStyle/>
-          <a:p>
-            <a:pPr indent="0" marL="0">
-              <a:buNone/>
-            </a:pPr>
-            <a:r>
-              <a:rPr lang="en-US" sz="1250" b="1" dirty="0">
-                <a:solidFill>
-                  <a:srgbClr val="2B2A28"/>
-                </a:solidFill>
-                <a:latin typeface="Calibri" pitchFamily="34" charset="0"/>
-                <a:ea typeface="Calibri" pitchFamily="34" charset="-122"/>
-                <a:cs typeface="Calibri" pitchFamily="34" charset="-120"/>
-              </a:rPr>
-              <a:t>Evidence ≠ popular belief</a:t>
-            </a:r>
-            <a:endParaRPr lang="en-US" sz="1250" dirty="0"/>
-          </a:p>
-          <a:p>
-            <a:pPr indent="0" marL="0">
-              <a:buNone/>
-            </a:pPr>
-            <a:r>
-              <a:rPr lang="en-US" sz="1000" dirty="0">
-                <a:solidFill>
-                  <a:srgbClr val="2B2A28"/>
-                </a:solidFill>
-                <a:latin typeface="Calibri" pitchFamily="34" charset="0"/>
-                <a:ea typeface="Calibri" pitchFamily="34" charset="-122"/>
-                <a:cs typeface="Calibri" pitchFamily="34" charset="-120"/>
-              </a:rPr>
-              <a:t>“Fasted training is bad for women” is not settled in the literature; the Skill makes the coach say so.</a:t>
+              <a:rPr lang="en-US" sz="1050" dirty="0">
+                <a:solidFill>
+                  <a:srgbClr val="2B2A28"/>
+                </a:solidFill>
+                <a:latin typeface="Calibri" pitchFamily="34" charset="0"/>
+                <a:ea typeface="Calibri" pitchFamily="34" charset="-122"/>
+                <a:cs typeface="Calibri" pitchFamily="34" charset="-120"/>
+              </a:rPr>
+              <a:t>Each eval config runs as a LangSmith experiment on the golden dataset (e.g. bloom-final), compared side by side.</a:t>
             </a:r>
             <a:endParaRPr lang="en-US" sz="1250" dirty="0"/>
           </a:p>
@@ -5779,6 +6459,734 @@
 <file path=ppt/slides/slide13.xml><?xml version="1.0" encoding="utf-8"?>
 <p:sld xmlns:a="http://schemas.openxmlformats.org/drawingml/2006/main" xmlns:r="http://schemas.openxmlformats.org/officeDocument/2006/relationships" xmlns:p="http://schemas.openxmlformats.org/presentationml/2006/main">
   <p:cSld name="Slide 13">
+    <p:bg>
+      <p:bgPr>
+        <a:solidFill>
+          <a:srgbClr val="FFFFFF"/>
+        </a:solidFill>
+      </p:bgPr>
+    </p:bg>
+    <p:spTree>
+      <p:nvGrpSpPr>
+        <p:cNvPr id="1" name=""/>
+        <p:cNvGrpSpPr/>
+        <p:nvPr/>
+      </p:nvGrpSpPr>
+      <p:grpSpPr>
+        <a:xfrm>
+          <a:off x="0" y="0"/>
+          <a:ext cx="0" cy="0"/>
+          <a:chOff x="0" y="0"/>
+          <a:chExt cx="0" cy="0"/>
+        </a:xfrm>
+      </p:grpSpPr>
+      <p:sp>
+        <p:nvSpPr>
+          <p:cNvPr id="2" name="Text 0"/>
+          <p:cNvSpPr txBox="1"/>
+          <p:nvPr/>
+        </p:nvSpPr>
+        <p:spPr>
+          <a:xfrm>
+            <a:off x="457200" y="292608"/>
+            <a:ext cx="8229600" cy="548640"/>
+          </a:xfrm>
+          <a:prstGeom prst="rect">
+            <a:avLst/>
+          </a:prstGeom>
+          <a:noFill/>
+          <a:ln/>
+        </p:spPr>
+        <p:txBody>
+          <a:bodyPr wrap="square" lIns="0" tIns="0" rIns="0" bIns="0" rtlCol="0" anchor="ctr"/>
+          <a:lstStyle/>
+          <a:p>
+            <a:pPr indent="0" marL="0">
+              <a:buNone/>
+            </a:pPr>
+            <a:r>
+              <a:rPr lang="en-US" sz="3000" b="1" dirty="0">
+                <a:solidFill>
+                  <a:srgbClr val="2B2A28"/>
+                </a:solidFill>
+                <a:latin typeface="Cambria" pitchFamily="34" charset="0"/>
+                <a:ea typeface="Cambria" pitchFamily="34" charset="-122"/>
+                <a:cs typeface="Cambria" pitchFamily="34" charset="-120"/>
+              </a:rPr>
+              <a:t>What broke on real data, and what I learned</a:t>
+            </a:r>
+            <a:endParaRPr lang="en-US" sz="3000" dirty="0"/>
+          </a:p>
+        </p:txBody>
+      </p:sp>
+      <p:sp>
+        <p:nvSpPr>
+          <p:cNvPr id="3" name="Text 1"/>
+          <p:cNvSpPr txBox="1"/>
+          <p:nvPr/>
+        </p:nvSpPr>
+        <p:spPr>
+          <a:xfrm>
+            <a:off x="457200" y="822960"/>
+            <a:ext cx="8229600" cy="320040"/>
+          </a:xfrm>
+          <a:prstGeom prst="rect">
+            <a:avLst/>
+          </a:prstGeom>
+          <a:noFill/>
+          <a:ln/>
+        </p:spPr>
+        <p:txBody>
+          <a:bodyPr wrap="square" lIns="0" tIns="0" rIns="0" bIns="0" rtlCol="0" anchor="ctr"/>
+          <a:lstStyle/>
+          <a:p>
+            <a:pPr indent="0" marL="0">
+              <a:buNone/>
+            </a:pPr>
+            <a:r>
+              <a:rPr lang="en-US" sz="1400" dirty="0">
+                <a:solidFill>
+                  <a:srgbClr val="6F6A62"/>
+                </a:solidFill>
+                <a:latin typeface="Calibri" pitchFamily="34" charset="0"/>
+                <a:ea typeface="Calibri" pitchFamily="34" charset="-122"/>
+                <a:cs typeface="Calibri" pitchFamily="34" charset="-120"/>
+              </a:rPr>
+              <a:t>Demo data passed every test; my own exports didn't</a:t>
+            </a:r>
+            <a:endParaRPr lang="en-US" sz="1400" dirty="0"/>
+          </a:p>
+        </p:txBody>
+      </p:sp>
+      <p:sp>
+        <p:nvSpPr>
+          <p:cNvPr id="4" name="Shape 2"/>
+          <p:cNvSpPr/>
+          <p:nvPr/>
+        </p:nvSpPr>
+        <p:spPr>
+          <a:xfrm>
+            <a:off x="457200" y="1280160"/>
+            <a:ext cx="4069080" cy="1005840"/>
+          </a:xfrm>
+          <a:prstGeom prst="roundRect">
+            <a:avLst>
+              <a:gd name="adj" fmla="val 10909"/>
+            </a:avLst>
+          </a:prstGeom>
+          <a:solidFill>
+            <a:srgbClr val="FFFFFF"/>
+          </a:solidFill>
+          <a:ln w="9525">
+            <a:solidFill>
+              <a:srgbClr val="E6E1D8"/>
+            </a:solidFill>
+            <a:prstDash val="solid"/>
+          </a:ln>
+        </p:spPr>
+      </p:sp>
+      <p:sp>
+        <p:nvSpPr>
+          <p:cNvPr id="5" name="Shape 3"/>
+          <p:cNvSpPr/>
+          <p:nvPr/>
+        </p:nvSpPr>
+        <p:spPr>
+          <a:xfrm>
+            <a:off x="594360" y="1435608"/>
+            <a:ext cx="237744" cy="237744"/>
+          </a:xfrm>
+          <a:prstGeom prst="ellipse">
+            <a:avLst/>
+          </a:prstGeom>
+          <a:solidFill>
+            <a:srgbClr val="138A72"/>
+          </a:solidFill>
+          <a:ln/>
+        </p:spPr>
+      </p:sp>
+      <p:sp>
+        <p:nvSpPr>
+          <p:cNvPr id="6" name="Text 4"/>
+          <p:cNvSpPr txBox="1"/>
+          <p:nvPr/>
+        </p:nvSpPr>
+        <p:spPr>
+          <a:xfrm>
+            <a:off x="960120" y="1371600"/>
+            <a:ext cx="3429000" cy="841248"/>
+          </a:xfrm>
+          <a:prstGeom prst="rect">
+            <a:avLst/>
+          </a:prstGeom>
+          <a:noFill/>
+          <a:ln/>
+        </p:spPr>
+        <p:txBody>
+          <a:bodyPr wrap="square" lIns="0" tIns="0" rIns="0" bIns="0" rtlCol="0" anchor="t"/>
+          <a:lstStyle/>
+          <a:p>
+            <a:pPr indent="0" marL="0">
+              <a:buNone/>
+            </a:pPr>
+            <a:r>
+              <a:rPr lang="en-US" sz="1250" b="1" dirty="0">
+                <a:solidFill>
+                  <a:srgbClr val="2B2A28"/>
+                </a:solidFill>
+                <a:latin typeface="Calibri" pitchFamily="34" charset="0"/>
+                <a:ea typeface="Calibri" pitchFamily="34" charset="-122"/>
+                <a:cs typeface="Calibri" pitchFamily="34" charset="-120"/>
+              </a:rPr>
+              <a:t>Timezones</a:t>
+            </a:r>
+            <a:endParaRPr lang="en-US" sz="1250" dirty="0"/>
+          </a:p>
+          <a:p>
+            <a:pPr indent="0" marL="0">
+              <a:buNone/>
+            </a:pPr>
+            <a:r>
+              <a:rPr lang="en-US" sz="1000" dirty="0">
+                <a:solidFill>
+                  <a:srgbClr val="2B2A28"/>
+                </a:solidFill>
+                <a:latin typeface="Calibri" pitchFamily="34" charset="0"/>
+                <a:ea typeface="Calibri" pitchFamily="34" charset="-122"/>
+                <a:cs typeface="Calibri" pitchFamily="34" charset="-120"/>
+              </a:rPr>
+              <a:t>Apple Health stamped everything +05:00 (the phone's zone at export) → workouts 4 h off, dedupe failed. Now one HOME_TZ for all sources.</a:t>
+            </a:r>
+            <a:endParaRPr lang="en-US" sz="1250" dirty="0"/>
+          </a:p>
+        </p:txBody>
+      </p:sp>
+      <p:sp>
+        <p:nvSpPr>
+          <p:cNvPr id="7" name="Shape 5"/>
+          <p:cNvSpPr/>
+          <p:nvPr/>
+        </p:nvSpPr>
+        <p:spPr>
+          <a:xfrm>
+            <a:off x="4617720" y="1280160"/>
+            <a:ext cx="4069080" cy="1005840"/>
+          </a:xfrm>
+          <a:prstGeom prst="roundRect">
+            <a:avLst>
+              <a:gd name="adj" fmla="val 10909"/>
+            </a:avLst>
+          </a:prstGeom>
+          <a:solidFill>
+            <a:srgbClr val="FFFFFF"/>
+          </a:solidFill>
+          <a:ln w="9525">
+            <a:solidFill>
+              <a:srgbClr val="E6E1D8"/>
+            </a:solidFill>
+            <a:prstDash val="solid"/>
+          </a:ln>
+        </p:spPr>
+      </p:sp>
+      <p:sp>
+        <p:nvSpPr>
+          <p:cNvPr id="8" name="Shape 6"/>
+          <p:cNvSpPr/>
+          <p:nvPr/>
+        </p:nvSpPr>
+        <p:spPr>
+          <a:xfrm>
+            <a:off x="4754880" y="1435608"/>
+            <a:ext cx="237744" cy="237744"/>
+          </a:xfrm>
+          <a:prstGeom prst="ellipse">
+            <a:avLst/>
+          </a:prstGeom>
+          <a:solidFill>
+            <a:srgbClr val="D86A2E"/>
+          </a:solidFill>
+          <a:ln/>
+        </p:spPr>
+      </p:sp>
+      <p:sp>
+        <p:nvSpPr>
+          <p:cNvPr id="9" name="Text 7"/>
+          <p:cNvSpPr txBox="1"/>
+          <p:nvPr/>
+        </p:nvSpPr>
+        <p:spPr>
+          <a:xfrm>
+            <a:off x="5120640" y="1371600"/>
+            <a:ext cx="3429000" cy="841248"/>
+          </a:xfrm>
+          <a:prstGeom prst="rect">
+            <a:avLst/>
+          </a:prstGeom>
+          <a:noFill/>
+          <a:ln/>
+        </p:spPr>
+        <p:txBody>
+          <a:bodyPr wrap="square" lIns="0" tIns="0" rIns="0" bIns="0" rtlCol="0" anchor="t"/>
+          <a:lstStyle/>
+          <a:p>
+            <a:pPr indent="0" marL="0">
+              <a:buNone/>
+            </a:pPr>
+            <a:r>
+              <a:rPr lang="en-US" sz="1250" b="1" dirty="0">
+                <a:solidFill>
+                  <a:srgbClr val="2B2A28"/>
+                </a:solidFill>
+                <a:latin typeface="Calibri" pitchFamily="34" charset="0"/>
+                <a:ea typeface="Calibri" pitchFamily="34" charset="-122"/>
+                <a:cs typeface="Calibri" pitchFamily="34" charset="-120"/>
+              </a:rPr>
+              <a:t>Same event, 3 apps</a:t>
+            </a:r>
+            <a:endParaRPr lang="en-US" sz="1250" dirty="0"/>
+          </a:p>
+          <a:p>
+            <a:pPr indent="0" marL="0">
+              <a:buNone/>
+            </a:pPr>
+            <a:r>
+              <a:rPr lang="en-US" sz="1000" dirty="0">
+                <a:solidFill>
+                  <a:srgbClr val="2B2A28"/>
+                </a:solidFill>
+                <a:latin typeface="Calibri" pitchFamily="34" charset="0"/>
+                <a:ea typeface="Calibri" pitchFamily="34" charset="-122"/>
+                <a:cs typeface="Calibri" pitchFamily="34" charset="-120"/>
+              </a:rPr>
+              <a:t>Mywellness mirrors the Watch (66 walks) and Withings (220 readings); the Watch re-records gym visits (55). Cross-source dedupe after every import.</a:t>
+            </a:r>
+            <a:endParaRPr lang="en-US" sz="1250" dirty="0"/>
+          </a:p>
+        </p:txBody>
+      </p:sp>
+      <p:sp>
+        <p:nvSpPr>
+          <p:cNvPr id="10" name="Shape 8"/>
+          <p:cNvSpPr/>
+          <p:nvPr/>
+        </p:nvSpPr>
+        <p:spPr>
+          <a:xfrm>
+            <a:off x="457200" y="2395728"/>
+            <a:ext cx="4069080" cy="1005840"/>
+          </a:xfrm>
+          <a:prstGeom prst="roundRect">
+            <a:avLst>
+              <a:gd name="adj" fmla="val 10909"/>
+            </a:avLst>
+          </a:prstGeom>
+          <a:solidFill>
+            <a:srgbClr val="FFFFFF"/>
+          </a:solidFill>
+          <a:ln w="9525">
+            <a:solidFill>
+              <a:srgbClr val="E6E1D8"/>
+            </a:solidFill>
+            <a:prstDash val="solid"/>
+          </a:ln>
+        </p:spPr>
+      </p:sp>
+      <p:sp>
+        <p:nvSpPr>
+          <p:cNvPr id="11" name="Shape 9"/>
+          <p:cNvSpPr/>
+          <p:nvPr/>
+        </p:nvSpPr>
+        <p:spPr>
+          <a:xfrm>
+            <a:off x="594360" y="2551176"/>
+            <a:ext cx="237744" cy="237744"/>
+          </a:xfrm>
+          <a:prstGeom prst="ellipse">
+            <a:avLst/>
+          </a:prstGeom>
+          <a:solidFill>
+            <a:srgbClr val="8A5FB3"/>
+          </a:solidFill>
+          <a:ln/>
+        </p:spPr>
+      </p:sp>
+      <p:sp>
+        <p:nvSpPr>
+          <p:cNvPr id="12" name="Text 10"/>
+          <p:cNvSpPr txBox="1"/>
+          <p:nvPr/>
+        </p:nvSpPr>
+        <p:spPr>
+          <a:xfrm>
+            <a:off x="960120" y="2487168"/>
+            <a:ext cx="3429000" cy="841248"/>
+          </a:xfrm>
+          <a:prstGeom prst="rect">
+            <a:avLst/>
+          </a:prstGeom>
+          <a:noFill/>
+          <a:ln/>
+        </p:spPr>
+        <p:txBody>
+          <a:bodyPr wrap="square" lIns="0" tIns="0" rIns="0" bIns="0" rtlCol="0" anchor="t"/>
+          <a:lstStyle/>
+          <a:p>
+            <a:pPr indent="0" marL="0">
+              <a:buNone/>
+            </a:pPr>
+            <a:r>
+              <a:rPr lang="en-US" sz="1250" b="1" dirty="0">
+                <a:solidFill>
+                  <a:srgbClr val="2B2A28"/>
+                </a:solidFill>
+                <a:latin typeface="Calibri" pitchFamily="34" charset="0"/>
+                <a:ea typeface="Calibri" pitchFamily="34" charset="-122"/>
+                <a:cs typeface="Calibri" pitchFamily="34" charset="-120"/>
+              </a:rPr>
+              <a:t>Format drift</a:t>
+            </a:r>
+            <a:endParaRPr lang="en-US" sz="1250" dirty="0"/>
+          </a:p>
+          <a:p>
+            <a:pPr indent="0" marL="0">
+              <a:buNone/>
+            </a:pPr>
+            <a:r>
+              <a:rPr lang="en-US" sz="1000" dirty="0">
+                <a:solidFill>
+                  <a:srgbClr val="2B2A28"/>
+                </a:solidFill>
+                <a:latin typeface="Calibri" pitchFamily="34" charset="0"/>
+                <a:ea typeface="Calibri" pitchFamily="34" charset="-122"/>
+                <a:cs typeface="Calibri" pitchFamily="34" charset="-120"/>
+              </a:rPr>
+              <a:t>Newer iOS writes VaginalBleeding* instead of MenstrualFlow*: 0 of 202 cycle records imported until fixed.</a:t>
+            </a:r>
+            <a:endParaRPr lang="en-US" sz="1250" dirty="0"/>
+          </a:p>
+        </p:txBody>
+      </p:sp>
+      <p:sp>
+        <p:nvSpPr>
+          <p:cNvPr id="13" name="Shape 11"/>
+          <p:cNvSpPr/>
+          <p:nvPr/>
+        </p:nvSpPr>
+        <p:spPr>
+          <a:xfrm>
+            <a:off x="4617720" y="2395728"/>
+            <a:ext cx="4069080" cy="1005840"/>
+          </a:xfrm>
+          <a:prstGeom prst="roundRect">
+            <a:avLst>
+              <a:gd name="adj" fmla="val 10909"/>
+            </a:avLst>
+          </a:prstGeom>
+          <a:solidFill>
+            <a:srgbClr val="FFFFFF"/>
+          </a:solidFill>
+          <a:ln w="9525">
+            <a:solidFill>
+              <a:srgbClr val="E6E1D8"/>
+            </a:solidFill>
+            <a:prstDash val="solid"/>
+          </a:ln>
+        </p:spPr>
+      </p:sp>
+      <p:sp>
+        <p:nvSpPr>
+          <p:cNvPr id="14" name="Shape 12"/>
+          <p:cNvSpPr/>
+          <p:nvPr/>
+        </p:nvSpPr>
+        <p:spPr>
+          <a:xfrm>
+            <a:off x="4754880" y="2551176"/>
+            <a:ext cx="237744" cy="237744"/>
+          </a:xfrm>
+          <a:prstGeom prst="ellipse">
+            <a:avLst/>
+          </a:prstGeom>
+          <a:solidFill>
+            <a:srgbClr val="C47A5A"/>
+          </a:solidFill>
+          <a:ln/>
+        </p:spPr>
+      </p:sp>
+      <p:sp>
+        <p:nvSpPr>
+          <p:cNvPr id="15" name="Text 13"/>
+          <p:cNvSpPr txBox="1"/>
+          <p:nvPr/>
+        </p:nvSpPr>
+        <p:spPr>
+          <a:xfrm>
+            <a:off x="5120640" y="2487168"/>
+            <a:ext cx="3429000" cy="841248"/>
+          </a:xfrm>
+          <a:prstGeom prst="rect">
+            <a:avLst/>
+          </a:prstGeom>
+          <a:noFill/>
+          <a:ln/>
+        </p:spPr>
+        <p:txBody>
+          <a:bodyPr wrap="square" lIns="0" tIns="0" rIns="0" bIns="0" rtlCol="0" anchor="t"/>
+          <a:lstStyle/>
+          <a:p>
+            <a:pPr indent="0" marL="0">
+              <a:buNone/>
+            </a:pPr>
+            <a:r>
+              <a:rPr lang="en-US" sz="1250" b="1" dirty="0">
+                <a:solidFill>
+                  <a:srgbClr val="2B2A28"/>
+                </a:solidFill>
+                <a:latin typeface="Calibri" pitchFamily="34" charset="0"/>
+                <a:ea typeface="Calibri" pitchFamily="34" charset="-122"/>
+                <a:cs typeface="Calibri" pitchFamily="34" charset="-120"/>
+              </a:rPr>
+              <a:t>Lenient self-check</a:t>
+            </a:r>
+            <a:endParaRPr lang="en-US" sz="1250" dirty="0"/>
+          </a:p>
+          <a:p>
+            <a:pPr indent="0" marL="0">
+              <a:buNone/>
+            </a:pPr>
+            <a:r>
+              <a:rPr lang="en-US" sz="1000" dirty="0">
+                <a:solidFill>
+                  <a:srgbClr val="2B2A28"/>
+                </a:solidFill>
+                <a:latin typeface="Calibri" pitchFamily="34" charset="0"/>
+                <a:ea typeface="Calibri" pitchFamily="34" charset="-122"/>
+                <a:cs typeface="Calibri" pitchFamily="34" charset="-120"/>
+              </a:rPr>
+              <a:t>The in-graph citation judge passed 95 % of answers; the offline eval found 22 % unsupported citations → per-claim judge.</a:t>
+            </a:r>
+            <a:endParaRPr lang="en-US" sz="1250" dirty="0"/>
+          </a:p>
+        </p:txBody>
+      </p:sp>
+      <p:sp>
+        <p:nvSpPr>
+          <p:cNvPr id="16" name="Shape 14"/>
+          <p:cNvSpPr/>
+          <p:nvPr/>
+        </p:nvSpPr>
+        <p:spPr>
+          <a:xfrm>
+            <a:off x="457200" y="3511296"/>
+            <a:ext cx="4069080" cy="1005840"/>
+          </a:xfrm>
+          <a:prstGeom prst="roundRect">
+            <a:avLst>
+              <a:gd name="adj" fmla="val 10909"/>
+            </a:avLst>
+          </a:prstGeom>
+          <a:solidFill>
+            <a:srgbClr val="FFFFFF"/>
+          </a:solidFill>
+          <a:ln w="9525">
+            <a:solidFill>
+              <a:srgbClr val="E6E1D8"/>
+            </a:solidFill>
+            <a:prstDash val="solid"/>
+          </a:ln>
+        </p:spPr>
+      </p:sp>
+      <p:sp>
+        <p:nvSpPr>
+          <p:cNvPr id="17" name="Shape 15"/>
+          <p:cNvSpPr/>
+          <p:nvPr/>
+        </p:nvSpPr>
+        <p:spPr>
+          <a:xfrm>
+            <a:off x="594360" y="3666744"/>
+            <a:ext cx="237744" cy="237744"/>
+          </a:xfrm>
+          <a:prstGeom prst="ellipse">
+            <a:avLst/>
+          </a:prstGeom>
+          <a:solidFill>
+            <a:srgbClr val="7C9A82"/>
+          </a:solidFill>
+          <a:ln/>
+        </p:spPr>
+      </p:sp>
+      <p:sp>
+        <p:nvSpPr>
+          <p:cNvPr id="18" name="Text 16"/>
+          <p:cNvSpPr txBox="1"/>
+          <p:nvPr/>
+        </p:nvSpPr>
+        <p:spPr>
+          <a:xfrm>
+            <a:off x="960120" y="3602736"/>
+            <a:ext cx="3429000" cy="841248"/>
+          </a:xfrm>
+          <a:prstGeom prst="rect">
+            <a:avLst/>
+          </a:prstGeom>
+          <a:noFill/>
+          <a:ln/>
+        </p:spPr>
+        <p:txBody>
+          <a:bodyPr wrap="square" lIns="0" tIns="0" rIns="0" bIns="0" rtlCol="0" anchor="t"/>
+          <a:lstStyle/>
+          <a:p>
+            <a:pPr indent="0" marL="0">
+              <a:buNone/>
+            </a:pPr>
+            <a:r>
+              <a:rPr lang="en-US" sz="1250" b="1" dirty="0">
+                <a:solidFill>
+                  <a:srgbClr val="2B2A28"/>
+                </a:solidFill>
+                <a:latin typeface="Calibri" pitchFamily="34" charset="0"/>
+                <a:ea typeface="Calibri" pitchFamily="34" charset="-122"/>
+                <a:cs typeface="Calibri" pitchFamily="34" charset="-120"/>
+              </a:rPr>
+              <a:t>Over-eager goals</a:t>
+            </a:r>
+            <a:endParaRPr lang="en-US" sz="1250" dirty="0"/>
+          </a:p>
+          <a:p>
+            <a:pPr indent="0" marL="0">
+              <a:buNone/>
+            </a:pPr>
+            <a:r>
+              <a:rPr lang="en-US" sz="1000" dirty="0">
+                <a:solidFill>
+                  <a:srgbClr val="2B2A28"/>
+                </a:solidFill>
+                <a:latin typeface="Calibri" pitchFamily="34" charset="0"/>
+                <a:ea typeface="Calibri" pitchFamily="34" charset="-122"/>
+                <a:cs typeface="Calibri" pitchFamily="34" charset="-120"/>
+              </a:rPr>
+              <a:t>“How should I adjust training this week?” triggered goal approval → stricter triage + a negative golden example.</a:t>
+            </a:r>
+            <a:endParaRPr lang="en-US" sz="1250" dirty="0"/>
+          </a:p>
+        </p:txBody>
+      </p:sp>
+      <p:sp>
+        <p:nvSpPr>
+          <p:cNvPr id="19" name="Shape 17"/>
+          <p:cNvSpPr/>
+          <p:nvPr/>
+        </p:nvSpPr>
+        <p:spPr>
+          <a:xfrm>
+            <a:off x="4617720" y="3511296"/>
+            <a:ext cx="4069080" cy="1005840"/>
+          </a:xfrm>
+          <a:prstGeom prst="roundRect">
+            <a:avLst>
+              <a:gd name="adj" fmla="val 10909"/>
+            </a:avLst>
+          </a:prstGeom>
+          <a:solidFill>
+            <a:srgbClr val="FFFFFF"/>
+          </a:solidFill>
+          <a:ln w="9525">
+            <a:solidFill>
+              <a:srgbClr val="E6E1D8"/>
+            </a:solidFill>
+            <a:prstDash val="solid"/>
+          </a:ln>
+        </p:spPr>
+      </p:sp>
+      <p:sp>
+        <p:nvSpPr>
+          <p:cNvPr id="20" name="Shape 18"/>
+          <p:cNvSpPr/>
+          <p:nvPr/>
+        </p:nvSpPr>
+        <p:spPr>
+          <a:xfrm>
+            <a:off x="4754880" y="3666744"/>
+            <a:ext cx="237744" cy="237744"/>
+          </a:xfrm>
+          <a:prstGeom prst="ellipse">
+            <a:avLst/>
+          </a:prstGeom>
+          <a:solidFill>
+            <a:srgbClr val="D8A7A0"/>
+          </a:solidFill>
+          <a:ln/>
+        </p:spPr>
+      </p:sp>
+      <p:sp>
+        <p:nvSpPr>
+          <p:cNvPr id="21" name="Text 19"/>
+          <p:cNvSpPr txBox="1"/>
+          <p:nvPr/>
+        </p:nvSpPr>
+        <p:spPr>
+          <a:xfrm>
+            <a:off x="5120640" y="3602736"/>
+            <a:ext cx="3429000" cy="841248"/>
+          </a:xfrm>
+          <a:prstGeom prst="rect">
+            <a:avLst/>
+          </a:prstGeom>
+          <a:noFill/>
+          <a:ln/>
+        </p:spPr>
+        <p:txBody>
+          <a:bodyPr wrap="square" lIns="0" tIns="0" rIns="0" bIns="0" rtlCol="0" anchor="t"/>
+          <a:lstStyle/>
+          <a:p>
+            <a:pPr indent="0" marL="0">
+              <a:buNone/>
+            </a:pPr>
+            <a:r>
+              <a:rPr lang="en-US" sz="1250" b="1" dirty="0">
+                <a:solidFill>
+                  <a:srgbClr val="2B2A28"/>
+                </a:solidFill>
+                <a:latin typeface="Calibri" pitchFamily="34" charset="0"/>
+                <a:ea typeface="Calibri" pitchFamily="34" charset="-122"/>
+                <a:cs typeface="Calibri" pitchFamily="34" charset="-120"/>
+              </a:rPr>
+              <a:t>Evidence ≠ popular belief</a:t>
+            </a:r>
+            <a:endParaRPr lang="en-US" sz="1250" dirty="0"/>
+          </a:p>
+          <a:p>
+            <a:pPr indent="0" marL="0">
+              <a:buNone/>
+            </a:pPr>
+            <a:r>
+              <a:rPr lang="en-US" sz="1000" dirty="0">
+                <a:solidFill>
+                  <a:srgbClr val="2B2A28"/>
+                </a:solidFill>
+                <a:latin typeface="Calibri" pitchFamily="34" charset="0"/>
+                <a:ea typeface="Calibri" pitchFamily="34" charset="-122"/>
+                <a:cs typeface="Calibri" pitchFamily="34" charset="-120"/>
+              </a:rPr>
+              <a:t>“Fasted training is bad for women” is not settled in the literature; the Skill makes the coach say so.</a:t>
+            </a:r>
+            <a:endParaRPr lang="en-US" sz="1250" dirty="0"/>
+          </a:p>
+        </p:txBody>
+      </p:sp>
+    </p:spTree>
+  </p:cSld>
+  <p:clrMapOvr>
+    <a:masterClrMapping/>
+  </p:clrMapOvr>
+</p:sld>
+</file>
+
+<file path=ppt/slides/slide14.xml><?xml version="1.0" encoding="utf-8"?>
+<p:sld xmlns:a="http://schemas.openxmlformats.org/drawingml/2006/main" xmlns:r="http://schemas.openxmlformats.org/officeDocument/2006/relationships" xmlns:p="http://schemas.openxmlformats.org/presentationml/2006/main">
+  <p:cSld name="Slide 14">
     <p:bg>
       <p:bgPr>
         <a:solidFill>
@@ -5988,7 +7396,7 @@
                 <a:ea typeface="Calibri" pitchFamily="34" charset="-122"/>
                 <a:cs typeface="Calibri" pitchFamily="34" charset="-120"/>
               </a:rPr>
-              <a:t>Safety routing 100 % on the golden set · cited, evidence-graded answers · real data from 4 sources in one timeline · goals only with approval</a:t>
+              <a:t>Safety routing 100 % on the golden set · cited, evidence-graded answers · real data from 4 sources in one timeline · goals only with approval · deployed behind a password on Railway</a:t>
             </a:r>
             <a:endParaRPr lang="en-US" sz="1500" dirty="0"/>
           </a:p>
@@ -6166,7 +7574,7 @@
                 <a:ea typeface="Calibri" pitchFamily="34" charset="-122"/>
                 <a:cs typeface="Calibri" pitchFamily="34" charset="-120"/>
               </a:rPr>
-              <a:t>Harder red-flag cases (indirect, multilingual) · real users with PCOS · wearable temperature/LH for ovulation · auth + deployment</a:t>
+              <a:t>Harder red-flag cases (indirect, multilingual) · real users with PCOS · wearable temperature/LH for ovulation · per-user accounts</a:t>
             </a:r>
             <a:endParaRPr lang="en-US" sz="1500" dirty="0"/>
           </a:p>
@@ -8138,7 +9546,7 @@
                 <a:ea typeface="Calibri" pitchFamily="34" charset="-122"/>
                 <a:cs typeface="Calibri" pitchFamily="34" charset="-120"/>
               </a:rPr>
-              <a:t>Live walkthrough: the same three flows as below</a:t>
+              <a:t>Live: bloom-production-4f69.up.railway.app (demo data, password on request)</a:t>
             </a:r>
             <a:endParaRPr lang="en-US" sz="1400" dirty="0"/>
           </a:p>

</xml_diff>